<commit_message>
feat: novos slides foram adicionados com novos exercícios
</commit_message>
<xml_diff>
--- a/Aula 02/IntroduçãoBD.pptx
+++ b/Aula 02/IntroduçãoBD.pptx
@@ -8,21 +8,23 @@
     <p:sldId id="256" r:id="rId2"/>
     <p:sldId id="263" r:id="rId3"/>
     <p:sldId id="257" r:id="rId4"/>
-    <p:sldId id="273" r:id="rId5"/>
-    <p:sldId id="281" r:id="rId6"/>
-    <p:sldId id="258" r:id="rId7"/>
-    <p:sldId id="260" r:id="rId8"/>
-    <p:sldId id="275" r:id="rId9"/>
-    <p:sldId id="274" r:id="rId10"/>
-    <p:sldId id="259" r:id="rId11"/>
-    <p:sldId id="271" r:id="rId12"/>
-    <p:sldId id="277" r:id="rId13"/>
-    <p:sldId id="276" r:id="rId14"/>
-    <p:sldId id="272" r:id="rId15"/>
-    <p:sldId id="264" r:id="rId16"/>
-    <p:sldId id="278" r:id="rId17"/>
-    <p:sldId id="280" r:id="rId18"/>
-    <p:sldId id="261" r:id="rId19"/>
+    <p:sldId id="282" r:id="rId5"/>
+    <p:sldId id="283" r:id="rId6"/>
+    <p:sldId id="273" r:id="rId7"/>
+    <p:sldId id="281" r:id="rId8"/>
+    <p:sldId id="258" r:id="rId9"/>
+    <p:sldId id="260" r:id="rId10"/>
+    <p:sldId id="275" r:id="rId11"/>
+    <p:sldId id="274" r:id="rId12"/>
+    <p:sldId id="259" r:id="rId13"/>
+    <p:sldId id="271" r:id="rId14"/>
+    <p:sldId id="277" r:id="rId15"/>
+    <p:sldId id="276" r:id="rId16"/>
+    <p:sldId id="272" r:id="rId17"/>
+    <p:sldId id="264" r:id="rId18"/>
+    <p:sldId id="278" r:id="rId19"/>
+    <p:sldId id="280" r:id="rId20"/>
+    <p:sldId id="261" r:id="rId21"/>
   </p:sldIdLst>
   <p:sldSz cx="12192000" cy="6858000"/>
   <p:notesSz cx="6858000" cy="9144000"/>
@@ -129,6 +131,14 @@
 </p:presentation>
 </file>
 
+<file path=ppt/revisionInfo.xml><?xml version="1.0" encoding="utf-8"?>
+<p1510:revInfo xmlns:a="http://schemas.openxmlformats.org/drawingml/2006/main" xmlns:r="http://schemas.openxmlformats.org/officeDocument/2006/relationships" xmlns:p1510="http://schemas.microsoft.com/office/powerpoint/2015/10/main">
+  <p1510:revLst>
+    <p1510:client id="{1F93AE48-05F5-F8FB-EF77-76387A15C63C}" v="497" dt="2026-08-07T21:09:55.351"/>
+  </p1510:revLst>
+</p1510:revInfo>
+</file>
+
 <file path=ppt/slideLayouts/slideLayout1.xml><?xml version="1.0" encoding="utf-8"?>
 <p:sldLayout xmlns:a="http://schemas.openxmlformats.org/drawingml/2006/main" xmlns:r="http://schemas.openxmlformats.org/officeDocument/2006/relationships" xmlns:p="http://schemas.openxmlformats.org/presentationml/2006/main" type="title" preserve="1">
   <p:cSld name="Slide de Título">
@@ -276,7 +286,7 @@
           <a:p>
             <a:fld id="{0293E696-207E-4958-8130-FF51108F7A86}" type="datetimeFigureOut">
               <a:rPr lang="pt-BR" smtClean="0"/>
-              <a:t>26/02/2026</a:t>
+              <a:t>07/08/2026</a:t>
             </a:fld>
             <a:endParaRPr lang="pt-BR"/>
           </a:p>
@@ -474,7 +484,7 @@
           <a:p>
             <a:fld id="{0293E696-207E-4958-8130-FF51108F7A86}" type="datetimeFigureOut">
               <a:rPr lang="pt-BR" smtClean="0"/>
-              <a:t>26/02/2026</a:t>
+              <a:t>07/08/2026</a:t>
             </a:fld>
             <a:endParaRPr lang="pt-BR"/>
           </a:p>
@@ -682,7 +692,7 @@
           <a:p>
             <a:fld id="{0293E696-207E-4958-8130-FF51108F7A86}" type="datetimeFigureOut">
               <a:rPr lang="pt-BR" smtClean="0"/>
-              <a:t>26/02/2026</a:t>
+              <a:t>07/08/2026</a:t>
             </a:fld>
             <a:endParaRPr lang="pt-BR"/>
           </a:p>
@@ -880,7 +890,7 @@
           <a:p>
             <a:fld id="{0293E696-207E-4958-8130-FF51108F7A86}" type="datetimeFigureOut">
               <a:rPr lang="pt-BR" smtClean="0"/>
-              <a:t>26/02/2026</a:t>
+              <a:t>07/08/2026</a:t>
             </a:fld>
             <a:endParaRPr lang="pt-BR"/>
           </a:p>
@@ -1155,7 +1165,7 @@
           <a:p>
             <a:fld id="{0293E696-207E-4958-8130-FF51108F7A86}" type="datetimeFigureOut">
               <a:rPr lang="pt-BR" smtClean="0"/>
-              <a:t>26/02/2026</a:t>
+              <a:t>07/08/2026</a:t>
             </a:fld>
             <a:endParaRPr lang="pt-BR"/>
           </a:p>
@@ -1420,7 +1430,7 @@
           <a:p>
             <a:fld id="{0293E696-207E-4958-8130-FF51108F7A86}" type="datetimeFigureOut">
               <a:rPr lang="pt-BR" smtClean="0"/>
-              <a:t>26/02/2026</a:t>
+              <a:t>07/08/2026</a:t>
             </a:fld>
             <a:endParaRPr lang="pt-BR"/>
           </a:p>
@@ -1832,7 +1842,7 @@
           <a:p>
             <a:fld id="{0293E696-207E-4958-8130-FF51108F7A86}" type="datetimeFigureOut">
               <a:rPr lang="pt-BR" smtClean="0"/>
-              <a:t>26/02/2026</a:t>
+              <a:t>07/08/2026</a:t>
             </a:fld>
             <a:endParaRPr lang="pt-BR"/>
           </a:p>
@@ -1973,7 +1983,7 @@
           <a:p>
             <a:fld id="{0293E696-207E-4958-8130-FF51108F7A86}" type="datetimeFigureOut">
               <a:rPr lang="pt-BR" smtClean="0"/>
-              <a:t>26/02/2026</a:t>
+              <a:t>07/08/2026</a:t>
             </a:fld>
             <a:endParaRPr lang="pt-BR"/>
           </a:p>
@@ -2086,7 +2096,7 @@
           <a:p>
             <a:fld id="{0293E696-207E-4958-8130-FF51108F7A86}" type="datetimeFigureOut">
               <a:rPr lang="pt-BR" smtClean="0"/>
-              <a:t>26/02/2026</a:t>
+              <a:t>07/08/2026</a:t>
             </a:fld>
             <a:endParaRPr lang="pt-BR"/>
           </a:p>
@@ -2397,7 +2407,7 @@
           <a:p>
             <a:fld id="{0293E696-207E-4958-8130-FF51108F7A86}" type="datetimeFigureOut">
               <a:rPr lang="pt-BR" smtClean="0"/>
-              <a:t>26/02/2026</a:t>
+              <a:t>07/08/2026</a:t>
             </a:fld>
             <a:endParaRPr lang="pt-BR"/>
           </a:p>
@@ -2685,7 +2695,7 @@
           <a:p>
             <a:fld id="{0293E696-207E-4958-8130-FF51108F7A86}" type="datetimeFigureOut">
               <a:rPr lang="pt-BR" smtClean="0"/>
-              <a:t>26/02/2026</a:t>
+              <a:t>07/08/2026</a:t>
             </a:fld>
             <a:endParaRPr lang="pt-BR"/>
           </a:p>
@@ -2926,7 +2936,7 @@
           <a:p>
             <a:fld id="{0293E696-207E-4958-8130-FF51108F7A86}" type="datetimeFigureOut">
               <a:rPr lang="pt-BR" smtClean="0"/>
-              <a:t>26/02/2026</a:t>
+              <a:t>07/08/2026</a:t>
             </a:fld>
             <a:endParaRPr lang="pt-BR"/>
           </a:p>
@@ -3597,6 +3607,809 @@
   <p:cSld>
     <p:spTree>
       <p:nvGrpSpPr>
+        <p:cNvPr id="1" name="">
+          <a:extLst>
+            <a:ext uri="{FF2B5EF4-FFF2-40B4-BE49-F238E27FC236}">
+              <a16:creationId xmlns:a16="http://schemas.microsoft.com/office/drawing/2014/main" id="{D783D399-0E22-4E3B-364D-D0374FFAB398}"/>
+            </a:ext>
+          </a:extLst>
+        </p:cNvPr>
+        <p:cNvGrpSpPr/>
+        <p:nvPr/>
+      </p:nvGrpSpPr>
+      <p:grpSpPr>
+        <a:xfrm>
+          <a:off x="0" y="0"/>
+          <a:ext cx="0" cy="0"/>
+          <a:chOff x="0" y="0"/>
+          <a:chExt cx="0" cy="0"/>
+        </a:xfrm>
+      </p:grpSpPr>
+      <p:sp>
+        <p:nvSpPr>
+          <p:cNvPr id="2" name="Título 1">
+            <a:extLst>
+              <a:ext uri="{FF2B5EF4-FFF2-40B4-BE49-F238E27FC236}">
+                <a16:creationId xmlns:a16="http://schemas.microsoft.com/office/drawing/2014/main" id="{8A7A24F0-3283-32F7-52BA-CB6E49BC7791}"/>
+              </a:ext>
+            </a:extLst>
+          </p:cNvPr>
+          <p:cNvSpPr>
+            <a:spLocks noGrp="1"/>
+          </p:cNvSpPr>
+          <p:nvPr>
+            <p:ph type="title"/>
+          </p:nvPr>
+        </p:nvSpPr>
+        <p:spPr/>
+        <p:txBody>
+          <a:bodyPr/>
+          <a:lstStyle/>
+          <a:p>
+            <a:endParaRPr lang="pt-BR"/>
+          </a:p>
+        </p:txBody>
+      </p:sp>
+      <p:sp>
+        <p:nvSpPr>
+          <p:cNvPr id="3" name="Espaço Reservado para Conteúdo 2">
+            <a:extLst>
+              <a:ext uri="{FF2B5EF4-FFF2-40B4-BE49-F238E27FC236}">
+                <a16:creationId xmlns:a16="http://schemas.microsoft.com/office/drawing/2014/main" id="{D5BD90EA-17CD-6205-3B39-487EEEC2E38C}"/>
+              </a:ext>
+            </a:extLst>
+          </p:cNvPr>
+          <p:cNvSpPr>
+            <a:spLocks noGrp="1"/>
+          </p:cNvSpPr>
+          <p:nvPr>
+            <p:ph idx="1"/>
+          </p:nvPr>
+        </p:nvSpPr>
+        <p:spPr/>
+        <p:txBody>
+          <a:bodyPr/>
+          <a:lstStyle/>
+          <a:p>
+            <a:endParaRPr lang="pt-BR"/>
+          </a:p>
+        </p:txBody>
+      </p:sp>
+      <p:pic>
+        <p:nvPicPr>
+          <p:cNvPr id="4" name="Imagem 3">
+            <a:extLst>
+              <a:ext uri="{FF2B5EF4-FFF2-40B4-BE49-F238E27FC236}">
+                <a16:creationId xmlns:a16="http://schemas.microsoft.com/office/drawing/2014/main" id="{11907E70-2A94-1DCF-C0B5-04AD6BA33CA4}"/>
+              </a:ext>
+            </a:extLst>
+          </p:cNvPr>
+          <p:cNvPicPr>
+            <a:picLocks noChangeAspect="1"/>
+          </p:cNvPicPr>
+          <p:nvPr/>
+        </p:nvPicPr>
+        <p:blipFill>
+          <a:blip r:embed="rId2">
+            <a:extLst>
+              <a:ext uri="{28A0092B-C50C-407E-A947-70E740481C1C}">
+                <a14:useLocalDpi xmlns:a14="http://schemas.microsoft.com/office/drawing/2010/main" val="0"/>
+              </a:ext>
+            </a:extLst>
+          </a:blip>
+          <a:stretch>
+            <a:fillRect/>
+          </a:stretch>
+        </p:blipFill>
+        <p:spPr>
+          <a:xfrm>
+            <a:off x="0" y="0"/>
+            <a:ext cx="12192000" cy="6858000"/>
+          </a:xfrm>
+          <a:prstGeom prst="rect">
+            <a:avLst/>
+          </a:prstGeom>
+        </p:spPr>
+      </p:pic>
+      <p:sp>
+        <p:nvSpPr>
+          <p:cNvPr id="5" name="CaixaDeTexto 4">
+            <a:extLst>
+              <a:ext uri="{FF2B5EF4-FFF2-40B4-BE49-F238E27FC236}">
+                <a16:creationId xmlns:a16="http://schemas.microsoft.com/office/drawing/2014/main" id="{269F7BF0-B16D-F005-3C99-877B66C74A60}"/>
+              </a:ext>
+            </a:extLst>
+          </p:cNvPr>
+          <p:cNvSpPr txBox="1"/>
+          <p:nvPr/>
+        </p:nvSpPr>
+        <p:spPr>
+          <a:xfrm>
+            <a:off x="4226902" y="498257"/>
+            <a:ext cx="3738196" cy="646331"/>
+          </a:xfrm>
+          <a:prstGeom prst="rect">
+            <a:avLst/>
+          </a:prstGeom>
+          <a:noFill/>
+        </p:spPr>
+        <p:txBody>
+          <a:bodyPr wrap="square" rtlCol="0">
+            <a:spAutoFit/>
+          </a:bodyPr>
+          <a:lstStyle/>
+          <a:p>
+            <a:pPr algn="ctr"/>
+            <a:r>
+              <a:rPr lang="pt-BR" sz="3600" dirty="0"/>
+              <a:t>CHAR x VARCHAR</a:t>
+            </a:r>
+          </a:p>
+        </p:txBody>
+      </p:sp>
+      <p:sp>
+        <p:nvSpPr>
+          <p:cNvPr id="7" name="CaixaDeTexto 6">
+            <a:extLst>
+              <a:ext uri="{FF2B5EF4-FFF2-40B4-BE49-F238E27FC236}">
+                <a16:creationId xmlns:a16="http://schemas.microsoft.com/office/drawing/2014/main" id="{BA5192B5-CF7F-F0C1-0A40-333626E1B5C5}"/>
+              </a:ext>
+            </a:extLst>
+          </p:cNvPr>
+          <p:cNvSpPr txBox="1"/>
+          <p:nvPr/>
+        </p:nvSpPr>
+        <p:spPr>
+          <a:xfrm>
+            <a:off x="838200" y="336950"/>
+            <a:ext cx="2467708" cy="1477328"/>
+          </a:xfrm>
+          <a:prstGeom prst="rect">
+            <a:avLst/>
+          </a:prstGeom>
+        </p:spPr>
+        <p:style>
+          <a:lnRef idx="0">
+            <a:schemeClr val="accent6"/>
+          </a:lnRef>
+          <a:fillRef idx="3">
+            <a:schemeClr val="accent6"/>
+          </a:fillRef>
+          <a:effectRef idx="3">
+            <a:schemeClr val="accent6"/>
+          </a:effectRef>
+          <a:fontRef idx="minor">
+            <a:schemeClr val="lt1"/>
+          </a:fontRef>
+        </p:style>
+        <p:txBody>
+          <a:bodyPr wrap="square" rtlCol="0">
+            <a:spAutoFit/>
+          </a:bodyPr>
+          <a:lstStyle/>
+          <a:p>
+            <a:r>
+              <a:rPr lang="en-US" dirty="0"/>
+              <a:t>String</a:t>
+            </a:r>
+          </a:p>
+          <a:p>
+            <a:endParaRPr lang="en-US" dirty="0"/>
+          </a:p>
+          <a:p>
+            <a:pPr marL="285750" indent="-285750">
+              <a:buFont typeface="Arial" panose="020B0604020202020204" pitchFamily="34" charset="0"/>
+              <a:buChar char="•"/>
+            </a:pPr>
+            <a:r>
+              <a:rPr lang="en-US" dirty="0"/>
+              <a:t>CHAR(n);</a:t>
+            </a:r>
+          </a:p>
+          <a:p>
+            <a:pPr marL="285750" indent="-285750">
+              <a:buFont typeface="Arial" panose="020B0604020202020204" pitchFamily="34" charset="0"/>
+              <a:buChar char="•"/>
+            </a:pPr>
+            <a:r>
+              <a:rPr lang="en-US" dirty="0"/>
+              <a:t>VARCHAR(n);</a:t>
+            </a:r>
+          </a:p>
+          <a:p>
+            <a:pPr marL="285750" indent="-285750">
+              <a:buFont typeface="Arial" panose="020B0604020202020204" pitchFamily="34" charset="0"/>
+              <a:buChar char="•"/>
+            </a:pPr>
+            <a:r>
+              <a:rPr lang="en-US" dirty="0"/>
+              <a:t>TEXT.</a:t>
+            </a:r>
+            <a:endParaRPr lang="pt-BR" dirty="0"/>
+          </a:p>
+        </p:txBody>
+      </p:sp>
+      <p:sp>
+        <p:nvSpPr>
+          <p:cNvPr id="13" name="Retângulo: Cantos Arredondados 12">
+            <a:extLst>
+              <a:ext uri="{FF2B5EF4-FFF2-40B4-BE49-F238E27FC236}">
+                <a16:creationId xmlns:a16="http://schemas.microsoft.com/office/drawing/2014/main" id="{76DEAC94-F68B-2F70-754B-561B241836AA}"/>
+              </a:ext>
+            </a:extLst>
+          </p:cNvPr>
+          <p:cNvSpPr/>
+          <p:nvPr/>
+        </p:nvSpPr>
+        <p:spPr>
+          <a:xfrm>
+            <a:off x="1169376" y="909949"/>
+            <a:ext cx="1371600" cy="606669"/>
+          </a:xfrm>
+          <a:prstGeom prst="roundRect">
+            <a:avLst/>
+          </a:prstGeom>
+          <a:solidFill>
+            <a:schemeClr val="accent2">
+              <a:alpha val="50000"/>
+            </a:schemeClr>
+          </a:solidFill>
+          <a:ln>
+            <a:noFill/>
+          </a:ln>
+        </p:spPr>
+        <p:style>
+          <a:lnRef idx="0">
+            <a:scrgbClr r="0" g="0" b="0"/>
+          </a:lnRef>
+          <a:fillRef idx="0">
+            <a:scrgbClr r="0" g="0" b="0"/>
+          </a:fillRef>
+          <a:effectRef idx="0">
+            <a:scrgbClr r="0" g="0" b="0"/>
+          </a:effectRef>
+          <a:fontRef idx="minor">
+            <a:schemeClr val="lt1"/>
+          </a:fontRef>
+        </p:style>
+        <p:txBody>
+          <a:bodyPr rtlCol="0" anchor="ctr"/>
+          <a:lstStyle/>
+          <a:p>
+            <a:pPr algn="ctr"/>
+            <a:endParaRPr lang="pt-BR"/>
+          </a:p>
+        </p:txBody>
+      </p:sp>
+      <p:pic>
+        <p:nvPicPr>
+          <p:cNvPr id="2050" name="Picture 2" descr="Caixa Tampa Sapato Medida: 20x30x12 - 3mm">
+            <a:extLst>
+              <a:ext uri="{FF2B5EF4-FFF2-40B4-BE49-F238E27FC236}">
+                <a16:creationId xmlns:a16="http://schemas.microsoft.com/office/drawing/2014/main" id="{4AF0CFC5-CB1E-C7ED-34C4-8C894B8CE690}"/>
+              </a:ext>
+            </a:extLst>
+          </p:cNvPr>
+          <p:cNvPicPr>
+            <a:picLocks noChangeAspect="1" noChangeArrowheads="1"/>
+          </p:cNvPicPr>
+          <p:nvPr/>
+        </p:nvPicPr>
+        <p:blipFill>
+          <a:blip r:embed="rId3">
+            <a:extLst>
+              <a:ext uri="{28A0092B-C50C-407E-A947-70E740481C1C}">
+                <a14:useLocalDpi xmlns:a14="http://schemas.microsoft.com/office/drawing/2010/main" val="0"/>
+              </a:ext>
+            </a:extLst>
+          </a:blip>
+          <a:srcRect/>
+          <a:stretch>
+            <a:fillRect/>
+          </a:stretch>
+        </p:blipFill>
+        <p:spPr bwMode="auto">
+          <a:xfrm>
+            <a:off x="1169376" y="2699726"/>
+            <a:ext cx="4648200" cy="3409950"/>
+          </a:xfrm>
+          <a:prstGeom prst="rect">
+            <a:avLst/>
+          </a:prstGeom>
+          <a:noFill/>
+          <a:extLst>
+            <a:ext uri="{909E8E84-426E-40DD-AFC4-6F175D3DCCD1}">
+              <a14:hiddenFill xmlns:a14="http://schemas.microsoft.com/office/drawing/2010/main">
+                <a:solidFill>
+                  <a:srgbClr val="FFFFFF"/>
+                </a:solidFill>
+              </a14:hiddenFill>
+            </a:ext>
+          </a:extLst>
+        </p:spPr>
+      </p:pic>
+      <p:pic>
+        <p:nvPicPr>
+          <p:cNvPr id="2054" name="Picture 6" descr="Mochila Saco em TNT CB 18505 | Célo Presentes Personalizados">
+            <a:extLst>
+              <a:ext uri="{FF2B5EF4-FFF2-40B4-BE49-F238E27FC236}">
+                <a16:creationId xmlns:a16="http://schemas.microsoft.com/office/drawing/2014/main" id="{9D1D9185-5185-BCC4-DAD0-A0103616B5B8}"/>
+              </a:ext>
+            </a:extLst>
+          </p:cNvPr>
+          <p:cNvPicPr>
+            <a:picLocks noChangeAspect="1" noChangeArrowheads="1"/>
+          </p:cNvPicPr>
+          <p:nvPr/>
+        </p:nvPicPr>
+        <p:blipFill>
+          <a:blip r:embed="rId4">
+            <a:extLst>
+              <a:ext uri="{28A0092B-C50C-407E-A947-70E740481C1C}">
+                <a14:useLocalDpi xmlns:a14="http://schemas.microsoft.com/office/drawing/2010/main" val="0"/>
+              </a:ext>
+            </a:extLst>
+          </a:blip>
+          <a:srcRect/>
+          <a:stretch>
+            <a:fillRect/>
+          </a:stretch>
+        </p:blipFill>
+        <p:spPr bwMode="auto">
+          <a:xfrm>
+            <a:off x="7342677" y="2497016"/>
+            <a:ext cx="3679947" cy="3679947"/>
+          </a:xfrm>
+          <a:prstGeom prst="rect">
+            <a:avLst/>
+          </a:prstGeom>
+          <a:noFill/>
+          <a:extLst>
+            <a:ext uri="{909E8E84-426E-40DD-AFC4-6F175D3DCCD1}">
+              <a14:hiddenFill xmlns:a14="http://schemas.microsoft.com/office/drawing/2010/main">
+                <a:solidFill>
+                  <a:srgbClr val="FFFFFF"/>
+                </a:solidFill>
+              </a14:hiddenFill>
+            </a:ext>
+          </a:extLst>
+        </p:spPr>
+      </p:pic>
+      <p:sp>
+        <p:nvSpPr>
+          <p:cNvPr id="14" name="CaixaDeTexto 13">
+            <a:extLst>
+              <a:ext uri="{FF2B5EF4-FFF2-40B4-BE49-F238E27FC236}">
+                <a16:creationId xmlns:a16="http://schemas.microsoft.com/office/drawing/2014/main" id="{F5A10B96-3C0E-403F-5742-D557A3C6C448}"/>
+              </a:ext>
+            </a:extLst>
+          </p:cNvPr>
+          <p:cNvSpPr txBox="1"/>
+          <p:nvPr/>
+        </p:nvSpPr>
+        <p:spPr>
+          <a:xfrm>
+            <a:off x="3031880" y="6311900"/>
+            <a:ext cx="923192" cy="461665"/>
+          </a:xfrm>
+          <a:prstGeom prst="rect">
+            <a:avLst/>
+          </a:prstGeom>
+          <a:noFill/>
+        </p:spPr>
+        <p:txBody>
+          <a:bodyPr wrap="square" rtlCol="0">
+            <a:spAutoFit/>
+          </a:bodyPr>
+          <a:lstStyle/>
+          <a:p>
+            <a:r>
+              <a:rPr lang="pt-BR" sz="2400" dirty="0"/>
+              <a:t>CHAR</a:t>
+            </a:r>
+          </a:p>
+        </p:txBody>
+      </p:sp>
+      <p:sp>
+        <p:nvSpPr>
+          <p:cNvPr id="15" name="CaixaDeTexto 14">
+            <a:extLst>
+              <a:ext uri="{FF2B5EF4-FFF2-40B4-BE49-F238E27FC236}">
+                <a16:creationId xmlns:a16="http://schemas.microsoft.com/office/drawing/2014/main" id="{5DB9C59B-3357-E4BD-B326-51F407B56D68}"/>
+              </a:ext>
+            </a:extLst>
+          </p:cNvPr>
+          <p:cNvSpPr txBox="1"/>
+          <p:nvPr/>
+        </p:nvSpPr>
+        <p:spPr>
+          <a:xfrm>
+            <a:off x="8491995" y="6227298"/>
+            <a:ext cx="1381309" cy="461665"/>
+          </a:xfrm>
+          <a:prstGeom prst="rect">
+            <a:avLst/>
+          </a:prstGeom>
+          <a:noFill/>
+        </p:spPr>
+        <p:txBody>
+          <a:bodyPr wrap="square" rtlCol="0">
+            <a:spAutoFit/>
+          </a:bodyPr>
+          <a:lstStyle/>
+          <a:p>
+            <a:r>
+              <a:rPr lang="pt-BR" sz="2400" dirty="0"/>
+              <a:t>VARCHAR</a:t>
+            </a:r>
+          </a:p>
+        </p:txBody>
+      </p:sp>
+      <p:sp>
+        <p:nvSpPr>
+          <p:cNvPr id="16" name="CaixaDeTexto 15">
+            <a:extLst>
+              <a:ext uri="{FF2B5EF4-FFF2-40B4-BE49-F238E27FC236}">
+                <a16:creationId xmlns:a16="http://schemas.microsoft.com/office/drawing/2014/main" id="{5D711219-99E7-7024-BCF6-8AF28AE1559F}"/>
+              </a:ext>
+            </a:extLst>
+          </p:cNvPr>
+          <p:cNvSpPr txBox="1"/>
+          <p:nvPr/>
+        </p:nvSpPr>
+        <p:spPr>
+          <a:xfrm>
+            <a:off x="8740377" y="4336989"/>
+            <a:ext cx="884544" cy="400110"/>
+          </a:xfrm>
+          <a:prstGeom prst="rect">
+            <a:avLst/>
+          </a:prstGeom>
+          <a:noFill/>
+        </p:spPr>
+        <p:txBody>
+          <a:bodyPr wrap="square" rtlCol="0">
+            <a:spAutoFit/>
+          </a:bodyPr>
+          <a:lstStyle/>
+          <a:p>
+            <a:r>
+              <a:rPr lang="pt-BR" sz="2000" dirty="0">
+                <a:solidFill>
+                  <a:schemeClr val="bg1"/>
+                </a:solidFill>
+              </a:rPr>
+              <a:t>Molde</a:t>
+            </a:r>
+            <a:r>
+              <a:rPr lang="pt-BR" dirty="0"/>
+              <a:t> </a:t>
+            </a:r>
+          </a:p>
+        </p:txBody>
+      </p:sp>
+      <p:sp>
+        <p:nvSpPr>
+          <p:cNvPr id="17" name="CaixaDeTexto 16">
+            <a:extLst>
+              <a:ext uri="{FF2B5EF4-FFF2-40B4-BE49-F238E27FC236}">
+                <a16:creationId xmlns:a16="http://schemas.microsoft.com/office/drawing/2014/main" id="{E09EC1C3-EA7A-9767-C1C8-C1EBD4CD0D15}"/>
+              </a:ext>
+            </a:extLst>
+          </p:cNvPr>
+          <p:cNvSpPr txBox="1"/>
+          <p:nvPr/>
+        </p:nvSpPr>
+        <p:spPr>
+          <a:xfrm>
+            <a:off x="3206327" y="3819988"/>
+            <a:ext cx="584195" cy="369332"/>
+          </a:xfrm>
+          <a:prstGeom prst="rect">
+            <a:avLst/>
+          </a:prstGeom>
+          <a:noFill/>
+          <a:ln>
+            <a:solidFill>
+              <a:schemeClr val="tx1"/>
+            </a:solidFill>
+          </a:ln>
+        </p:spPr>
+        <p:txBody>
+          <a:bodyPr wrap="square" lIns="91440" tIns="45720" rIns="91440" bIns="45720" rtlCol="0" anchor="t">
+            <a:spAutoFit/>
+          </a:bodyPr>
+          <a:lstStyle/>
+          <a:p>
+            <a:r>
+              <a:rPr lang="pt-BR">
+                <a:solidFill>
+                  <a:srgbClr val="000000"/>
+                </a:solidFill>
+              </a:rPr>
+              <a:t>Fixo</a:t>
+            </a:r>
+            <a:endParaRPr lang="pt-BR" dirty="0">
+              <a:solidFill>
+                <a:srgbClr val="000000"/>
+              </a:solidFill>
+            </a:endParaRPr>
+          </a:p>
+        </p:txBody>
+      </p:sp>
+    </p:spTree>
+    <p:extLst>
+      <p:ext uri="{BB962C8B-B14F-4D97-AF65-F5344CB8AC3E}">
+        <p14:creationId xmlns:p14="http://schemas.microsoft.com/office/powerpoint/2010/main" val="1799090681"/>
+      </p:ext>
+    </p:extLst>
+  </p:cSld>
+  <p:clrMapOvr>
+    <a:masterClrMapping/>
+  </p:clrMapOvr>
+</p:sld>
+</file>
+
+<file path=ppt/slides/slide11.xml><?xml version="1.0" encoding="utf-8"?>
+<p:sld xmlns:a="http://schemas.openxmlformats.org/drawingml/2006/main" xmlns:r="http://schemas.openxmlformats.org/officeDocument/2006/relationships" xmlns:p="http://schemas.openxmlformats.org/presentationml/2006/main">
+  <p:cSld>
+    <p:spTree>
+      <p:nvGrpSpPr>
+        <p:cNvPr id="1" name="">
+          <a:extLst>
+            <a:ext uri="{FF2B5EF4-FFF2-40B4-BE49-F238E27FC236}">
+              <a16:creationId xmlns:a16="http://schemas.microsoft.com/office/drawing/2014/main" id="{29B56F5F-7B90-0286-D0AC-48C7B7559BF2}"/>
+            </a:ext>
+          </a:extLst>
+        </p:cNvPr>
+        <p:cNvGrpSpPr/>
+        <p:nvPr/>
+      </p:nvGrpSpPr>
+      <p:grpSpPr>
+        <a:xfrm>
+          <a:off x="0" y="0"/>
+          <a:ext cx="0" cy="0"/>
+          <a:chOff x="0" y="0"/>
+          <a:chExt cx="0" cy="0"/>
+        </a:xfrm>
+      </p:grpSpPr>
+      <p:pic>
+        <p:nvPicPr>
+          <p:cNvPr id="4" name="Imagem 3">
+            <a:extLst>
+              <a:ext uri="{FF2B5EF4-FFF2-40B4-BE49-F238E27FC236}">
+                <a16:creationId xmlns:a16="http://schemas.microsoft.com/office/drawing/2014/main" id="{52668181-0034-E595-230A-A3E3760967D5}"/>
+              </a:ext>
+            </a:extLst>
+          </p:cNvPr>
+          <p:cNvPicPr>
+            <a:picLocks noChangeAspect="1"/>
+          </p:cNvPicPr>
+          <p:nvPr/>
+        </p:nvPicPr>
+        <p:blipFill>
+          <a:blip r:embed="rId2">
+            <a:extLst>
+              <a:ext uri="{28A0092B-C50C-407E-A947-70E740481C1C}">
+                <a14:useLocalDpi xmlns:a14="http://schemas.microsoft.com/office/drawing/2010/main" val="0"/>
+              </a:ext>
+            </a:extLst>
+          </a:blip>
+          <a:stretch>
+            <a:fillRect/>
+          </a:stretch>
+        </p:blipFill>
+        <p:spPr>
+          <a:xfrm>
+            <a:off x="0" y="0"/>
+            <a:ext cx="12192000" cy="6858000"/>
+          </a:xfrm>
+          <a:prstGeom prst="rect">
+            <a:avLst/>
+          </a:prstGeom>
+        </p:spPr>
+      </p:pic>
+      <p:sp>
+        <p:nvSpPr>
+          <p:cNvPr id="5" name="CaixaDeTexto 4">
+            <a:extLst>
+              <a:ext uri="{FF2B5EF4-FFF2-40B4-BE49-F238E27FC236}">
+                <a16:creationId xmlns:a16="http://schemas.microsoft.com/office/drawing/2014/main" id="{8432ACAF-4D47-7516-C29C-FEB386218782}"/>
+              </a:ext>
+            </a:extLst>
+          </p:cNvPr>
+          <p:cNvSpPr txBox="1"/>
+          <p:nvPr/>
+        </p:nvSpPr>
+        <p:spPr>
+          <a:xfrm>
+            <a:off x="4955931" y="404324"/>
+            <a:ext cx="2203939" cy="646331"/>
+          </a:xfrm>
+          <a:prstGeom prst="rect">
+            <a:avLst/>
+          </a:prstGeom>
+          <a:noFill/>
+        </p:spPr>
+        <p:txBody>
+          <a:bodyPr wrap="square" rtlCol="0">
+            <a:spAutoFit/>
+          </a:bodyPr>
+          <a:lstStyle/>
+          <a:p>
+            <a:r>
+              <a:rPr lang="en-US" sz="3600" dirty="0"/>
+              <a:t>Null X Zero</a:t>
+            </a:r>
+            <a:endParaRPr lang="pt-BR" sz="3600" dirty="0"/>
+          </a:p>
+        </p:txBody>
+      </p:sp>
+      <p:sp>
+        <p:nvSpPr>
+          <p:cNvPr id="7" name="CaixaDeTexto 6">
+            <a:extLst>
+              <a:ext uri="{FF2B5EF4-FFF2-40B4-BE49-F238E27FC236}">
+                <a16:creationId xmlns:a16="http://schemas.microsoft.com/office/drawing/2014/main" id="{F30DE2AE-7BE7-BB5B-0BD0-416B40B9805B}"/>
+              </a:ext>
+            </a:extLst>
+          </p:cNvPr>
+          <p:cNvSpPr txBox="1"/>
+          <p:nvPr/>
+        </p:nvSpPr>
+        <p:spPr>
+          <a:xfrm>
+            <a:off x="1521069" y="1690688"/>
+            <a:ext cx="3434862" cy="1354217"/>
+          </a:xfrm>
+          <a:prstGeom prst="rect">
+            <a:avLst/>
+          </a:prstGeom>
+          <a:noFill/>
+        </p:spPr>
+        <p:txBody>
+          <a:bodyPr wrap="square" rtlCol="0">
+            <a:spAutoFit/>
+          </a:bodyPr>
+          <a:lstStyle/>
+          <a:p>
+            <a:r>
+              <a:rPr lang="pt-BR" sz="2800" dirty="0"/>
+              <a:t>	     </a:t>
+            </a:r>
+            <a:r>
+              <a:rPr lang="pt-BR" sz="2800" dirty="0" err="1"/>
+              <a:t>Null</a:t>
+            </a:r>
+            <a:endParaRPr lang="pt-BR" sz="2800" dirty="0"/>
+          </a:p>
+          <a:p>
+            <a:endParaRPr lang="pt-BR" dirty="0"/>
+          </a:p>
+          <a:p>
+            <a:pPr marL="285750" indent="-285750" algn="ctr">
+              <a:buFont typeface="Wingdings" panose="05000000000000000000" pitchFamily="2" charset="2"/>
+              <a:buChar char="Ø"/>
+            </a:pPr>
+            <a:r>
+              <a:rPr lang="pt-BR" dirty="0"/>
+              <a:t>É a </a:t>
+            </a:r>
+            <a:r>
+              <a:rPr lang="pt-BR" b="1" dirty="0"/>
+              <a:t>ausência</a:t>
+            </a:r>
+            <a:r>
+              <a:rPr lang="pt-BR" dirty="0"/>
+              <a:t> de valor, indicando que o valor é desconhecido.</a:t>
+            </a:r>
+          </a:p>
+        </p:txBody>
+      </p:sp>
+      <p:sp>
+        <p:nvSpPr>
+          <p:cNvPr id="8" name="CaixaDeTexto 7">
+            <a:extLst>
+              <a:ext uri="{FF2B5EF4-FFF2-40B4-BE49-F238E27FC236}">
+                <a16:creationId xmlns:a16="http://schemas.microsoft.com/office/drawing/2014/main" id="{A08F799F-3F3F-9C9A-C4A7-A84CC4A27875}"/>
+              </a:ext>
+            </a:extLst>
+          </p:cNvPr>
+          <p:cNvSpPr txBox="1"/>
+          <p:nvPr/>
+        </p:nvSpPr>
+        <p:spPr>
+          <a:xfrm>
+            <a:off x="7159870" y="1552188"/>
+            <a:ext cx="3285392" cy="1631216"/>
+          </a:xfrm>
+          <a:prstGeom prst="rect">
+            <a:avLst/>
+          </a:prstGeom>
+          <a:noFill/>
+        </p:spPr>
+        <p:txBody>
+          <a:bodyPr wrap="square" rtlCol="0">
+            <a:spAutoFit/>
+          </a:bodyPr>
+          <a:lstStyle/>
+          <a:p>
+            <a:r>
+              <a:rPr lang="pt-BR" sz="2800" dirty="0"/>
+              <a:t>	    Zero</a:t>
+            </a:r>
+          </a:p>
+          <a:p>
+            <a:endParaRPr lang="pt-BR" dirty="0"/>
+          </a:p>
+          <a:p>
+            <a:pPr marL="285750" indent="-285750" algn="ctr">
+              <a:buFont typeface="Wingdings" panose="05000000000000000000" pitchFamily="2" charset="2"/>
+              <a:buChar char="Ø"/>
+            </a:pPr>
+            <a:r>
+              <a:rPr lang="pt-BR" dirty="0"/>
+              <a:t>É um valor numérico </a:t>
+            </a:r>
+            <a:r>
+              <a:rPr lang="pt-BR" b="1" dirty="0"/>
+              <a:t>definido</a:t>
+            </a:r>
+            <a:r>
+              <a:rPr lang="pt-BR" dirty="0"/>
+              <a:t>, indicando que o valor foi preenchido.</a:t>
+            </a:r>
+          </a:p>
+        </p:txBody>
+      </p:sp>
+      <p:pic>
+        <p:nvPicPr>
+          <p:cNvPr id="2" name="Imagem 1" descr="Zero é o rolo vazio; Null é a ausência do próprio suporte., gerada com IA">
+            <a:extLst>
+              <a:ext uri="{FF2B5EF4-FFF2-40B4-BE49-F238E27FC236}">
+                <a16:creationId xmlns:a16="http://schemas.microsoft.com/office/drawing/2014/main" id="{32E4DFF3-0FD1-ABB6-2E50-7109DB40288B}"/>
+              </a:ext>
+            </a:extLst>
+          </p:cNvPr>
+          <p:cNvPicPr>
+            <a:picLocks noChangeAspect="1"/>
+          </p:cNvPicPr>
+          <p:nvPr/>
+        </p:nvPicPr>
+        <p:blipFill>
+          <a:blip r:embed="rId3"/>
+          <a:stretch>
+            <a:fillRect/>
+          </a:stretch>
+        </p:blipFill>
+        <p:spPr>
+          <a:xfrm>
+            <a:off x="3189265" y="3044646"/>
+            <a:ext cx="5727611" cy="3280089"/>
+          </a:xfrm>
+          <a:prstGeom prst="rect">
+            <a:avLst/>
+          </a:prstGeom>
+        </p:spPr>
+      </p:pic>
+    </p:spTree>
+    <p:extLst>
+      <p:ext uri="{BB962C8B-B14F-4D97-AF65-F5344CB8AC3E}">
+        <p14:creationId xmlns:p14="http://schemas.microsoft.com/office/powerpoint/2010/main" val="1358784351"/>
+      </p:ext>
+    </p:extLst>
+  </p:cSld>
+  <p:clrMapOvr>
+    <a:masterClrMapping/>
+  </p:clrMapOvr>
+</p:sld>
+</file>
+
+<file path=ppt/slides/slide12.xml><?xml version="1.0" encoding="utf-8"?>
+<p:sld xmlns:a="http://schemas.openxmlformats.org/drawingml/2006/main" xmlns:r="http://schemas.openxmlformats.org/officeDocument/2006/relationships" xmlns:p="http://schemas.openxmlformats.org/presentationml/2006/main">
+  <p:cSld>
+    <p:spTree>
+      <p:nvGrpSpPr>
         <p:cNvPr id="1" name=""/>
         <p:cNvGrpSpPr/>
         <p:nvPr/>
@@ -3955,7 +4768,7 @@
 </p:sld>
 </file>
 
-<file path=ppt/slides/slide11.xml><?xml version="1.0" encoding="utf-8"?>
+<file path=ppt/slides/slide13.xml><?xml version="1.0" encoding="utf-8"?>
 <p:sld xmlns:a="http://schemas.openxmlformats.org/drawingml/2006/main" xmlns:r="http://schemas.openxmlformats.org/officeDocument/2006/relationships" xmlns:p="http://schemas.openxmlformats.org/presentationml/2006/main">
   <p:cSld>
     <p:spTree>
@@ -4093,7 +4906,7 @@
 </p:sld>
 </file>
 
-<file path=ppt/slides/slide12.xml><?xml version="1.0" encoding="utf-8"?>
+<file path=ppt/slides/slide14.xml><?xml version="1.0" encoding="utf-8"?>
 <p:sld xmlns:a="http://schemas.openxmlformats.org/drawingml/2006/main" xmlns:r="http://schemas.openxmlformats.org/officeDocument/2006/relationships" xmlns:p="http://schemas.openxmlformats.org/presentationml/2006/main">
   <p:cSld>
     <p:spTree>
@@ -4308,7 +5121,7 @@
 </p:sld>
 </file>
 
-<file path=ppt/slides/slide13.xml><?xml version="1.0" encoding="utf-8"?>
+<file path=ppt/slides/slide15.xml><?xml version="1.0" encoding="utf-8"?>
 <p:sld xmlns:a="http://schemas.openxmlformats.org/drawingml/2006/main" xmlns:r="http://schemas.openxmlformats.org/officeDocument/2006/relationships" xmlns:p="http://schemas.openxmlformats.org/presentationml/2006/main">
   <p:cSld>
     <p:spTree>
@@ -4936,7 +5749,7 @@
 </p:sld>
 </file>
 
-<file path=ppt/slides/slide14.xml><?xml version="1.0" encoding="utf-8"?>
+<file path=ppt/slides/slide16.xml><?xml version="1.0" encoding="utf-8"?>
 <p:sld xmlns:a="http://schemas.openxmlformats.org/drawingml/2006/main" xmlns:r="http://schemas.openxmlformats.org/officeDocument/2006/relationships" xmlns:p="http://schemas.openxmlformats.org/presentationml/2006/main">
   <p:cSld>
     <p:spTree>
@@ -5448,7 +6261,7 @@
 </p:sld>
 </file>
 
-<file path=ppt/slides/slide15.xml><?xml version="1.0" encoding="utf-8"?>
+<file path=ppt/slides/slide17.xml><?xml version="1.0" encoding="utf-8"?>
 <p:sld xmlns:a="http://schemas.openxmlformats.org/drawingml/2006/main" xmlns:r="http://schemas.openxmlformats.org/officeDocument/2006/relationships" xmlns:p="http://schemas.openxmlformats.org/presentationml/2006/main">
   <p:cSld>
     <p:spTree>
@@ -5882,7 +6695,7 @@
 </p:sld>
 </file>
 
-<file path=ppt/slides/slide16.xml><?xml version="1.0" encoding="utf-8"?>
+<file path=ppt/slides/slide18.xml><?xml version="1.0" encoding="utf-8"?>
 <p:sld xmlns:a="http://schemas.openxmlformats.org/drawingml/2006/main" xmlns:r="http://schemas.openxmlformats.org/officeDocument/2006/relationships" xmlns:p="http://schemas.openxmlformats.org/presentationml/2006/main">
   <p:cSld>
     <p:spTree>
@@ -6158,7 +6971,7 @@
 </p:sld>
 </file>
 
-<file path=ppt/slides/slide17.xml><?xml version="1.0" encoding="utf-8"?>
+<file path=ppt/slides/slide19.xml><?xml version="1.0" encoding="utf-8"?>
 <p:sld xmlns:a="http://schemas.openxmlformats.org/drawingml/2006/main" xmlns:r="http://schemas.openxmlformats.org/officeDocument/2006/relationships" xmlns:p="http://schemas.openxmlformats.org/presentationml/2006/main">
   <p:cSld>
     <p:spTree>
@@ -6397,177 +7210,6 @@
     <p:extLst>
       <p:ext uri="{BB962C8B-B14F-4D97-AF65-F5344CB8AC3E}">
         <p14:creationId xmlns:p14="http://schemas.microsoft.com/office/powerpoint/2010/main" val="4191261173"/>
-      </p:ext>
-    </p:extLst>
-  </p:cSld>
-  <p:clrMapOvr>
-    <a:masterClrMapping/>
-  </p:clrMapOvr>
-</p:sld>
-</file>
-
-<file path=ppt/slides/slide18.xml><?xml version="1.0" encoding="utf-8"?>
-<p:sld xmlns:a="http://schemas.openxmlformats.org/drawingml/2006/main" xmlns:r="http://schemas.openxmlformats.org/officeDocument/2006/relationships" xmlns:p="http://schemas.openxmlformats.org/presentationml/2006/main">
-  <p:cSld>
-    <p:spTree>
-      <p:nvGrpSpPr>
-        <p:cNvPr id="1" name="">
-          <a:extLst>
-            <a:ext uri="{FF2B5EF4-FFF2-40B4-BE49-F238E27FC236}">
-              <a16:creationId xmlns:a16="http://schemas.microsoft.com/office/drawing/2014/main" id="{A9F73D6E-FC32-50DA-1CBC-9FDC465B155C}"/>
-            </a:ext>
-          </a:extLst>
-        </p:cNvPr>
-        <p:cNvGrpSpPr/>
-        <p:nvPr/>
-      </p:nvGrpSpPr>
-      <p:grpSpPr>
-        <a:xfrm>
-          <a:off x="0" y="0"/>
-          <a:ext cx="0" cy="0"/>
-          <a:chOff x="0" y="0"/>
-          <a:chExt cx="0" cy="0"/>
-        </a:xfrm>
-      </p:grpSpPr>
-      <p:sp>
-        <p:nvSpPr>
-          <p:cNvPr id="2" name="Título 1">
-            <a:extLst>
-              <a:ext uri="{FF2B5EF4-FFF2-40B4-BE49-F238E27FC236}">
-                <a16:creationId xmlns:a16="http://schemas.microsoft.com/office/drawing/2014/main" id="{7D33F163-C736-9349-5711-22D353FEFD1A}"/>
-              </a:ext>
-            </a:extLst>
-          </p:cNvPr>
-          <p:cNvSpPr>
-            <a:spLocks noGrp="1"/>
-          </p:cNvSpPr>
-          <p:nvPr>
-            <p:ph type="title"/>
-          </p:nvPr>
-        </p:nvSpPr>
-        <p:spPr/>
-        <p:txBody>
-          <a:bodyPr/>
-          <a:lstStyle/>
-          <a:p>
-            <a:endParaRPr lang="pt-BR"/>
-          </a:p>
-        </p:txBody>
-      </p:sp>
-      <p:sp>
-        <p:nvSpPr>
-          <p:cNvPr id="3" name="Espaço Reservado para Conteúdo 2">
-            <a:extLst>
-              <a:ext uri="{FF2B5EF4-FFF2-40B4-BE49-F238E27FC236}">
-                <a16:creationId xmlns:a16="http://schemas.microsoft.com/office/drawing/2014/main" id="{13625611-E7FA-1D72-494A-0AFBC3CF9FB2}"/>
-              </a:ext>
-            </a:extLst>
-          </p:cNvPr>
-          <p:cNvSpPr>
-            <a:spLocks noGrp="1"/>
-          </p:cNvSpPr>
-          <p:nvPr>
-            <p:ph idx="1"/>
-          </p:nvPr>
-        </p:nvSpPr>
-        <p:spPr/>
-        <p:txBody>
-          <a:bodyPr/>
-          <a:lstStyle/>
-          <a:p>
-            <a:endParaRPr lang="pt-BR"/>
-          </a:p>
-        </p:txBody>
-      </p:sp>
-      <p:pic>
-        <p:nvPicPr>
-          <p:cNvPr id="4" name="Imagem 3">
-            <a:extLst>
-              <a:ext uri="{FF2B5EF4-FFF2-40B4-BE49-F238E27FC236}">
-                <a16:creationId xmlns:a16="http://schemas.microsoft.com/office/drawing/2014/main" id="{743371B3-3339-12F0-DD89-453EBF0A0ED8}"/>
-              </a:ext>
-            </a:extLst>
-          </p:cNvPr>
-          <p:cNvPicPr>
-            <a:picLocks noChangeAspect="1"/>
-          </p:cNvPicPr>
-          <p:nvPr/>
-        </p:nvPicPr>
-        <p:blipFill>
-          <a:blip r:embed="rId2">
-            <a:extLst>
-              <a:ext uri="{28A0092B-C50C-407E-A947-70E740481C1C}">
-                <a14:useLocalDpi xmlns:a14="http://schemas.microsoft.com/office/drawing/2010/main" val="0"/>
-              </a:ext>
-            </a:extLst>
-          </a:blip>
-          <a:stretch>
-            <a:fillRect/>
-          </a:stretch>
-        </p:blipFill>
-        <p:spPr>
-          <a:xfrm>
-            <a:off x="0" y="0"/>
-            <a:ext cx="12192000" cy="6858000"/>
-          </a:xfrm>
-          <a:prstGeom prst="rect">
-            <a:avLst/>
-          </a:prstGeom>
-        </p:spPr>
-      </p:pic>
-      <p:sp>
-        <p:nvSpPr>
-          <p:cNvPr id="5" name="CaixaDeTexto 4">
-            <a:extLst>
-              <a:ext uri="{FF2B5EF4-FFF2-40B4-BE49-F238E27FC236}">
-                <a16:creationId xmlns:a16="http://schemas.microsoft.com/office/drawing/2014/main" id="{C30338DA-9061-D8D4-B5A5-66A14A047FD4}"/>
-              </a:ext>
-            </a:extLst>
-          </p:cNvPr>
-          <p:cNvSpPr txBox="1"/>
-          <p:nvPr/>
-        </p:nvSpPr>
-        <p:spPr>
-          <a:xfrm>
-            <a:off x="3924300" y="2413337"/>
-            <a:ext cx="4343400" cy="1938992"/>
-          </a:xfrm>
-          <a:prstGeom prst="rect">
-            <a:avLst/>
-          </a:prstGeom>
-          <a:noFill/>
-        </p:spPr>
-        <p:txBody>
-          <a:bodyPr wrap="square" rtlCol="0">
-            <a:spAutoFit/>
-          </a:bodyPr>
-          <a:lstStyle/>
-          <a:p>
-            <a:pPr algn="ctr"/>
-            <a:r>
-              <a:rPr lang="en-US" sz="6000" dirty="0">
-                <a:solidFill>
-                  <a:schemeClr val="accent5">
-                    <a:lumMod val="75000"/>
-                  </a:schemeClr>
-                </a:solidFill>
-              </a:rPr>
-              <a:t>AULA CONCLUÍDA!</a:t>
-            </a:r>
-            <a:endParaRPr lang="pt-BR" sz="6000" dirty="0">
-              <a:solidFill>
-                <a:schemeClr val="accent5">
-                  <a:lumMod val="75000"/>
-                </a:schemeClr>
-              </a:solidFill>
-            </a:endParaRPr>
-          </a:p>
-        </p:txBody>
-      </p:sp>
-    </p:spTree>
-    <p:extLst>
-      <p:ext uri="{BB962C8B-B14F-4D97-AF65-F5344CB8AC3E}">
-        <p14:creationId xmlns:p14="http://schemas.microsoft.com/office/powerpoint/2010/main" val="3532846639"/>
       </p:ext>
     </p:extLst>
   </p:cSld>
@@ -6987,6 +7629,177 @@
 </p:sld>
 </file>
 
+<file path=ppt/slides/slide20.xml><?xml version="1.0" encoding="utf-8"?>
+<p:sld xmlns:a="http://schemas.openxmlformats.org/drawingml/2006/main" xmlns:r="http://schemas.openxmlformats.org/officeDocument/2006/relationships" xmlns:p="http://schemas.openxmlformats.org/presentationml/2006/main">
+  <p:cSld>
+    <p:spTree>
+      <p:nvGrpSpPr>
+        <p:cNvPr id="1" name="">
+          <a:extLst>
+            <a:ext uri="{FF2B5EF4-FFF2-40B4-BE49-F238E27FC236}">
+              <a16:creationId xmlns:a16="http://schemas.microsoft.com/office/drawing/2014/main" id="{A9F73D6E-FC32-50DA-1CBC-9FDC465B155C}"/>
+            </a:ext>
+          </a:extLst>
+        </p:cNvPr>
+        <p:cNvGrpSpPr/>
+        <p:nvPr/>
+      </p:nvGrpSpPr>
+      <p:grpSpPr>
+        <a:xfrm>
+          <a:off x="0" y="0"/>
+          <a:ext cx="0" cy="0"/>
+          <a:chOff x="0" y="0"/>
+          <a:chExt cx="0" cy="0"/>
+        </a:xfrm>
+      </p:grpSpPr>
+      <p:sp>
+        <p:nvSpPr>
+          <p:cNvPr id="2" name="Título 1">
+            <a:extLst>
+              <a:ext uri="{FF2B5EF4-FFF2-40B4-BE49-F238E27FC236}">
+                <a16:creationId xmlns:a16="http://schemas.microsoft.com/office/drawing/2014/main" id="{7D33F163-C736-9349-5711-22D353FEFD1A}"/>
+              </a:ext>
+            </a:extLst>
+          </p:cNvPr>
+          <p:cNvSpPr>
+            <a:spLocks noGrp="1"/>
+          </p:cNvSpPr>
+          <p:nvPr>
+            <p:ph type="title"/>
+          </p:nvPr>
+        </p:nvSpPr>
+        <p:spPr/>
+        <p:txBody>
+          <a:bodyPr/>
+          <a:lstStyle/>
+          <a:p>
+            <a:endParaRPr lang="pt-BR"/>
+          </a:p>
+        </p:txBody>
+      </p:sp>
+      <p:sp>
+        <p:nvSpPr>
+          <p:cNvPr id="3" name="Espaço Reservado para Conteúdo 2">
+            <a:extLst>
+              <a:ext uri="{FF2B5EF4-FFF2-40B4-BE49-F238E27FC236}">
+                <a16:creationId xmlns:a16="http://schemas.microsoft.com/office/drawing/2014/main" id="{13625611-E7FA-1D72-494A-0AFBC3CF9FB2}"/>
+              </a:ext>
+            </a:extLst>
+          </p:cNvPr>
+          <p:cNvSpPr>
+            <a:spLocks noGrp="1"/>
+          </p:cNvSpPr>
+          <p:nvPr>
+            <p:ph idx="1"/>
+          </p:nvPr>
+        </p:nvSpPr>
+        <p:spPr/>
+        <p:txBody>
+          <a:bodyPr/>
+          <a:lstStyle/>
+          <a:p>
+            <a:endParaRPr lang="pt-BR"/>
+          </a:p>
+        </p:txBody>
+      </p:sp>
+      <p:pic>
+        <p:nvPicPr>
+          <p:cNvPr id="4" name="Imagem 3">
+            <a:extLst>
+              <a:ext uri="{FF2B5EF4-FFF2-40B4-BE49-F238E27FC236}">
+                <a16:creationId xmlns:a16="http://schemas.microsoft.com/office/drawing/2014/main" id="{743371B3-3339-12F0-DD89-453EBF0A0ED8}"/>
+              </a:ext>
+            </a:extLst>
+          </p:cNvPr>
+          <p:cNvPicPr>
+            <a:picLocks noChangeAspect="1"/>
+          </p:cNvPicPr>
+          <p:nvPr/>
+        </p:nvPicPr>
+        <p:blipFill>
+          <a:blip r:embed="rId2">
+            <a:extLst>
+              <a:ext uri="{28A0092B-C50C-407E-A947-70E740481C1C}">
+                <a14:useLocalDpi xmlns:a14="http://schemas.microsoft.com/office/drawing/2010/main" val="0"/>
+              </a:ext>
+            </a:extLst>
+          </a:blip>
+          <a:stretch>
+            <a:fillRect/>
+          </a:stretch>
+        </p:blipFill>
+        <p:spPr>
+          <a:xfrm>
+            <a:off x="0" y="0"/>
+            <a:ext cx="12192000" cy="6858000"/>
+          </a:xfrm>
+          <a:prstGeom prst="rect">
+            <a:avLst/>
+          </a:prstGeom>
+        </p:spPr>
+      </p:pic>
+      <p:sp>
+        <p:nvSpPr>
+          <p:cNvPr id="5" name="CaixaDeTexto 4">
+            <a:extLst>
+              <a:ext uri="{FF2B5EF4-FFF2-40B4-BE49-F238E27FC236}">
+                <a16:creationId xmlns:a16="http://schemas.microsoft.com/office/drawing/2014/main" id="{C30338DA-9061-D8D4-B5A5-66A14A047FD4}"/>
+              </a:ext>
+            </a:extLst>
+          </p:cNvPr>
+          <p:cNvSpPr txBox="1"/>
+          <p:nvPr/>
+        </p:nvSpPr>
+        <p:spPr>
+          <a:xfrm>
+            <a:off x="3924300" y="2413337"/>
+            <a:ext cx="4343400" cy="1938992"/>
+          </a:xfrm>
+          <a:prstGeom prst="rect">
+            <a:avLst/>
+          </a:prstGeom>
+          <a:noFill/>
+        </p:spPr>
+        <p:txBody>
+          <a:bodyPr wrap="square" rtlCol="0">
+            <a:spAutoFit/>
+          </a:bodyPr>
+          <a:lstStyle/>
+          <a:p>
+            <a:pPr algn="ctr"/>
+            <a:r>
+              <a:rPr lang="en-US" sz="6000" dirty="0">
+                <a:solidFill>
+                  <a:schemeClr val="accent5">
+                    <a:lumMod val="75000"/>
+                  </a:schemeClr>
+                </a:solidFill>
+              </a:rPr>
+              <a:t>AULA CONCLUÍDA!</a:t>
+            </a:r>
+            <a:endParaRPr lang="pt-BR" sz="6000" dirty="0">
+              <a:solidFill>
+                <a:schemeClr val="accent5">
+                  <a:lumMod val="75000"/>
+                </a:schemeClr>
+              </a:solidFill>
+            </a:endParaRPr>
+          </a:p>
+        </p:txBody>
+      </p:sp>
+    </p:spTree>
+    <p:extLst>
+      <p:ext uri="{BB962C8B-B14F-4D97-AF65-F5344CB8AC3E}">
+        <p14:creationId xmlns:p14="http://schemas.microsoft.com/office/powerpoint/2010/main" val="3532846639"/>
+      </p:ext>
+    </p:extLst>
+  </p:cSld>
+  <p:clrMapOvr>
+    <a:masterClrMapping/>
+  </p:clrMapOvr>
+</p:sld>
+</file>
+
 <file path=ppt/slides/slide3.xml><?xml version="1.0" encoding="utf-8"?>
 <p:sld xmlns:a="http://schemas.openxmlformats.org/drawingml/2006/main" xmlns:r="http://schemas.openxmlformats.org/officeDocument/2006/relationships" xmlns:p="http://schemas.openxmlformats.org/presentationml/2006/main">
   <p:cSld>
@@ -7226,6 +8039,633 @@
 </file>
 
 <file path=ppt/slides/slide4.xml><?xml version="1.0" encoding="utf-8"?>
+<p:sld xmlns:a="http://schemas.openxmlformats.org/drawingml/2006/main" xmlns:r="http://schemas.openxmlformats.org/officeDocument/2006/relationships" xmlns:p="http://schemas.openxmlformats.org/presentationml/2006/main">
+  <p:cSld>
+    <p:spTree>
+      <p:nvGrpSpPr>
+        <p:cNvPr id="1" name="">
+          <a:extLst>
+            <a:ext uri="{FF2B5EF4-FFF2-40B4-BE49-F238E27FC236}">
+              <a16:creationId xmlns:a16="http://schemas.microsoft.com/office/drawing/2014/main" id="{ECEFE617-CC02-4ED5-C455-962B76E9F045}"/>
+            </a:ext>
+          </a:extLst>
+        </p:cNvPr>
+        <p:cNvGrpSpPr/>
+        <p:nvPr/>
+      </p:nvGrpSpPr>
+      <p:grpSpPr>
+        <a:xfrm>
+          <a:off x="0" y="0"/>
+          <a:ext cx="0" cy="0"/>
+          <a:chOff x="0" y="0"/>
+          <a:chExt cx="0" cy="0"/>
+        </a:xfrm>
+      </p:grpSpPr>
+      <p:pic>
+        <p:nvPicPr>
+          <p:cNvPr id="5" name="Imagem 4">
+            <a:extLst>
+              <a:ext uri="{FF2B5EF4-FFF2-40B4-BE49-F238E27FC236}">
+                <a16:creationId xmlns:a16="http://schemas.microsoft.com/office/drawing/2014/main" id="{FA3506CD-E9C5-DE03-25AA-8C552385BB10}"/>
+              </a:ext>
+            </a:extLst>
+          </p:cNvPr>
+          <p:cNvPicPr>
+            <a:picLocks noChangeAspect="1"/>
+          </p:cNvPicPr>
+          <p:nvPr/>
+        </p:nvPicPr>
+        <p:blipFill>
+          <a:blip r:embed="rId2">
+            <a:extLst>
+              <a:ext uri="{28A0092B-C50C-407E-A947-70E740481C1C}">
+                <a14:useLocalDpi xmlns:a14="http://schemas.microsoft.com/office/drawing/2010/main" val="0"/>
+              </a:ext>
+            </a:extLst>
+          </a:blip>
+          <a:stretch>
+            <a:fillRect/>
+          </a:stretch>
+        </p:blipFill>
+        <p:spPr>
+          <a:xfrm>
+            <a:off x="0" y="0"/>
+            <a:ext cx="12192000" cy="6858000"/>
+          </a:xfrm>
+          <a:prstGeom prst="rect">
+            <a:avLst/>
+          </a:prstGeom>
+        </p:spPr>
+      </p:pic>
+      <p:sp>
+        <p:nvSpPr>
+          <p:cNvPr id="10" name="CaixaDeTexto 9">
+            <a:extLst>
+              <a:ext uri="{FF2B5EF4-FFF2-40B4-BE49-F238E27FC236}">
+                <a16:creationId xmlns:a16="http://schemas.microsoft.com/office/drawing/2014/main" id="{8440ADD3-6A84-8052-BD6F-F23396EA5F4F}"/>
+              </a:ext>
+            </a:extLst>
+          </p:cNvPr>
+          <p:cNvSpPr txBox="1"/>
+          <p:nvPr/>
+        </p:nvSpPr>
+        <p:spPr>
+          <a:xfrm>
+            <a:off x="4179958" y="285357"/>
+            <a:ext cx="3821351" cy="584775"/>
+          </a:xfrm>
+          <a:prstGeom prst="rect">
+            <a:avLst/>
+          </a:prstGeom>
+          <a:noFill/>
+        </p:spPr>
+        <p:txBody>
+          <a:bodyPr wrap="square" lIns="91440" tIns="45720" rIns="91440" bIns="45720" rtlCol="0" anchor="t">
+            <a:spAutoFit/>
+          </a:bodyPr>
+          <a:lstStyle/>
+          <a:p>
+            <a:r>
+              <a:rPr lang="en-US" sz="3200" dirty="0" err="1"/>
+              <a:t>Contexto</a:t>
+            </a:r>
+            <a:r>
+              <a:rPr lang="en-US" sz="3200" dirty="0"/>
+              <a:t> e </a:t>
+            </a:r>
+            <a:r>
+              <a:rPr lang="en-US" sz="3200" dirty="0" err="1"/>
+              <a:t>Motivação</a:t>
+            </a:r>
+            <a:endParaRPr lang="en-US" sz="3200" dirty="0" err="1">
+              <a:ea typeface="Calibri"/>
+              <a:cs typeface="Calibri"/>
+            </a:endParaRPr>
+          </a:p>
+        </p:txBody>
+      </p:sp>
+      <p:sp>
+        <p:nvSpPr>
+          <p:cNvPr id="2" name="Retângulo: Cantos Arredondados 1">
+            <a:extLst>
+              <a:ext uri="{FF2B5EF4-FFF2-40B4-BE49-F238E27FC236}">
+                <a16:creationId xmlns:a16="http://schemas.microsoft.com/office/drawing/2014/main" id="{2B185811-5466-F8F3-3592-C3839B3A2DB9}"/>
+              </a:ext>
+            </a:extLst>
+          </p:cNvPr>
+          <p:cNvSpPr/>
+          <p:nvPr/>
+        </p:nvSpPr>
+        <p:spPr>
+          <a:xfrm>
+            <a:off x="912253" y="1105436"/>
+            <a:ext cx="10335295" cy="5076422"/>
+          </a:xfrm>
+          <a:prstGeom prst="roundRect">
+            <a:avLst/>
+          </a:prstGeom>
+        </p:spPr>
+        <p:style>
+          <a:lnRef idx="1">
+            <a:schemeClr val="accent5"/>
+          </a:lnRef>
+          <a:fillRef idx="2">
+            <a:schemeClr val="accent5"/>
+          </a:fillRef>
+          <a:effectRef idx="1">
+            <a:schemeClr val="accent5"/>
+          </a:effectRef>
+          <a:fontRef idx="minor">
+            <a:schemeClr val="dk1"/>
+          </a:fontRef>
+        </p:style>
+        <p:txBody>
+          <a:bodyPr rtlCol="0" anchor="ctr"/>
+          <a:lstStyle/>
+          <a:p>
+            <a:pPr algn="ctr"/>
+            <a:endParaRPr lang="pt-BR"/>
+          </a:p>
+        </p:txBody>
+      </p:sp>
+      <p:sp>
+        <p:nvSpPr>
+          <p:cNvPr id="3" name="CaixaDeTexto 2">
+            <a:extLst>
+              <a:ext uri="{FF2B5EF4-FFF2-40B4-BE49-F238E27FC236}">
+                <a16:creationId xmlns:a16="http://schemas.microsoft.com/office/drawing/2014/main" id="{B32AD348-D62C-6CC5-2323-46A57DDD08CD}"/>
+              </a:ext>
+            </a:extLst>
+          </p:cNvPr>
+          <p:cNvSpPr txBox="1"/>
+          <p:nvPr/>
+        </p:nvSpPr>
+        <p:spPr>
+          <a:xfrm>
+            <a:off x="1298619" y="1459605"/>
+            <a:ext cx="9616225" cy="1754326"/>
+          </a:xfrm>
+          <a:prstGeom prst="rect">
+            <a:avLst/>
+          </a:prstGeom>
+          <a:noFill/>
+        </p:spPr>
+        <p:txBody>
+          <a:bodyPr rot="0" spcFirstLastPara="0" vertOverflow="overflow" horzOverflow="overflow" vert="horz" wrap="square" lIns="91440" tIns="45720" rIns="91440" bIns="45720" numCol="1" spcCol="0" rtlCol="0" fromWordArt="0" anchor="t" anchorCtr="0" forceAA="0" compatLnSpc="1">
+            <a:prstTxWarp prst="textNoShape">
+              <a:avLst/>
+            </a:prstTxWarp>
+            <a:spAutoFit/>
+          </a:bodyPr>
+          <a:lstStyle/>
+          <a:p>
+            <a:r>
+              <a:rPr lang="pt-BR">
+                <a:ea typeface="Calibri"/>
+                <a:cs typeface="Calibri"/>
+              </a:rPr>
+              <a:t>Por que não usar ferramentas simples, como planilhas e arquivos?</a:t>
+            </a:r>
+          </a:p>
+          <a:p>
+            <a:endParaRPr lang="pt-BR" dirty="0">
+              <a:ea typeface="Calibri"/>
+              <a:cs typeface="Calibri"/>
+            </a:endParaRPr>
+          </a:p>
+          <a:p>
+            <a:pPr marL="285750" indent="-285750">
+              <a:buFont typeface="Calibri"/>
+              <a:buChar char="-"/>
+            </a:pPr>
+            <a:r>
+              <a:rPr lang="pt-BR" dirty="0">
+                <a:ea typeface="Calibri"/>
+                <a:cs typeface="Calibri"/>
+              </a:rPr>
+              <a:t>Duplicação e Incon</a:t>
+            </a:r>
+            <a:r>
+              <a:rPr lang="pt-BR">
+                <a:ea typeface="Calibri"/>
+                <a:cs typeface="Calibri"/>
+              </a:rPr>
+              <a:t>sistência - dados inconsistentes para falta de atualização total;</a:t>
+            </a:r>
+            <a:endParaRPr lang="pt-BR" dirty="0">
+              <a:ea typeface="Calibri"/>
+              <a:cs typeface="Calibri"/>
+            </a:endParaRPr>
+          </a:p>
+          <a:p>
+            <a:pPr marL="285750" indent="-285750">
+              <a:buFont typeface="Calibri"/>
+              <a:buChar char="-"/>
+            </a:pPr>
+            <a:r>
+              <a:rPr lang="pt-BR">
+                <a:ea typeface="Calibri"/>
+                <a:cs typeface="Calibri"/>
+              </a:rPr>
+              <a:t>Falta de Controle de Acesso Simultâneo - risco de sobrescrita e perda de dados;</a:t>
+            </a:r>
+          </a:p>
+          <a:p>
+            <a:pPr marL="285750" indent="-285750">
+              <a:buFont typeface="Calibri"/>
+              <a:buChar char="-"/>
+            </a:pPr>
+            <a:r>
+              <a:rPr lang="pt-BR" dirty="0">
+                <a:ea typeface="Calibri"/>
+                <a:cs typeface="Calibri"/>
+              </a:rPr>
+              <a:t>Escalabilidade Limitada – planilhas travam com muit</a:t>
+            </a:r>
+            <a:r>
+              <a:rPr lang="pt-BR">
+                <a:ea typeface="Calibri"/>
+                <a:cs typeface="Calibri"/>
+              </a:rPr>
+              <a:t>as linhas;</a:t>
+            </a:r>
+            <a:endParaRPr lang="pt-BR" dirty="0">
+              <a:ea typeface="Calibri"/>
+              <a:cs typeface="Calibri"/>
+            </a:endParaRPr>
+          </a:p>
+          <a:p>
+            <a:pPr marL="285750" indent="-285750">
+              <a:buFont typeface="Calibri"/>
+              <a:buChar char="-"/>
+            </a:pPr>
+            <a:r>
+              <a:rPr lang="pt-BR">
+                <a:ea typeface="Calibri"/>
+                <a:cs typeface="Calibri"/>
+              </a:rPr>
+              <a:t>Falta de Integridade – falta de ferramentas de controle de tipo .</a:t>
+            </a:r>
+            <a:endParaRPr lang="pt-BR" dirty="0">
+              <a:ea typeface="Calibri"/>
+              <a:cs typeface="Calibri"/>
+            </a:endParaRPr>
+          </a:p>
+        </p:txBody>
+      </p:sp>
+      <p:pic>
+        <p:nvPicPr>
+          <p:cNvPr id="4" name="Imagem 3" descr="Planilha Excel: Modelos Prontos e Dashboards Profissionais">
+            <a:extLst>
+              <a:ext uri="{FF2B5EF4-FFF2-40B4-BE49-F238E27FC236}">
+                <a16:creationId xmlns:a16="http://schemas.microsoft.com/office/drawing/2014/main" id="{755BD4DF-995D-D287-404F-399E0E371B33}"/>
+              </a:ext>
+            </a:extLst>
+          </p:cNvPr>
+          <p:cNvPicPr>
+            <a:picLocks noChangeAspect="1"/>
+          </p:cNvPicPr>
+          <p:nvPr/>
+        </p:nvPicPr>
+        <p:blipFill>
+          <a:blip r:embed="rId3"/>
+          <a:stretch>
+            <a:fillRect/>
+          </a:stretch>
+        </p:blipFill>
+        <p:spPr>
+          <a:xfrm>
+            <a:off x="1858448" y="3645660"/>
+            <a:ext cx="3495272" cy="2110257"/>
+          </a:xfrm>
+          <a:prstGeom prst="round2DiagRect">
+            <a:avLst>
+              <a:gd name="adj1" fmla="val 16667"/>
+              <a:gd name="adj2" fmla="val 0"/>
+            </a:avLst>
+          </a:prstGeom>
+          <a:ln w="88900" cap="sq">
+            <a:solidFill>
+              <a:srgbClr val="FFFFFF"/>
+            </a:solidFill>
+            <a:miter lim="800000"/>
+          </a:ln>
+          <a:effectLst>
+            <a:outerShdw blurRad="254000" algn="tl" rotWithShape="0">
+              <a:srgbClr val="000000">
+                <a:alpha val="43000"/>
+              </a:srgbClr>
+            </a:outerShdw>
+          </a:effectLst>
+        </p:spPr>
+      </p:pic>
+      <p:pic>
+        <p:nvPicPr>
+          <p:cNvPr id="9" name="Imagem 8" descr="Arquivos - ícones de arquivos e pastas grátis">
+            <a:extLst>
+              <a:ext uri="{FF2B5EF4-FFF2-40B4-BE49-F238E27FC236}">
+                <a16:creationId xmlns:a16="http://schemas.microsoft.com/office/drawing/2014/main" id="{12A9D290-85B6-0C31-4319-464A6F4E6135}"/>
+              </a:ext>
+            </a:extLst>
+          </p:cNvPr>
+          <p:cNvPicPr>
+            <a:picLocks noChangeAspect="1"/>
+          </p:cNvPicPr>
+          <p:nvPr/>
+        </p:nvPicPr>
+        <p:blipFill>
+          <a:blip r:embed="rId4"/>
+          <a:stretch>
+            <a:fillRect/>
+          </a:stretch>
+        </p:blipFill>
+        <p:spPr>
+          <a:xfrm>
+            <a:off x="6366055" y="3538068"/>
+            <a:ext cx="3602596" cy="2325443"/>
+          </a:xfrm>
+          <a:prstGeom prst="round2DiagRect">
+            <a:avLst>
+              <a:gd name="adj1" fmla="val 16667"/>
+              <a:gd name="adj2" fmla="val 0"/>
+            </a:avLst>
+          </a:prstGeom>
+          <a:ln w="88900" cap="sq">
+            <a:solidFill>
+              <a:srgbClr val="FFFFFF"/>
+            </a:solidFill>
+            <a:miter lim="800000"/>
+          </a:ln>
+          <a:effectLst>
+            <a:outerShdw blurRad="254000" algn="tl" rotWithShape="0">
+              <a:srgbClr val="000000">
+                <a:alpha val="43000"/>
+              </a:srgbClr>
+            </a:outerShdw>
+          </a:effectLst>
+        </p:spPr>
+      </p:pic>
+    </p:spTree>
+    <p:extLst>
+      <p:ext uri="{BB962C8B-B14F-4D97-AF65-F5344CB8AC3E}">
+        <p14:creationId xmlns:p14="http://schemas.microsoft.com/office/powerpoint/2010/main" val="3130157152"/>
+      </p:ext>
+    </p:extLst>
+  </p:cSld>
+  <p:clrMapOvr>
+    <a:masterClrMapping/>
+  </p:clrMapOvr>
+</p:sld>
+</file>
+
+<file path=ppt/slides/slide5.xml><?xml version="1.0" encoding="utf-8"?>
+<p:sld xmlns:a="http://schemas.openxmlformats.org/drawingml/2006/main" xmlns:r="http://schemas.openxmlformats.org/officeDocument/2006/relationships" xmlns:p="http://schemas.openxmlformats.org/presentationml/2006/main">
+  <p:cSld>
+    <p:spTree>
+      <p:nvGrpSpPr>
+        <p:cNvPr id="1" name="">
+          <a:extLst>
+            <a:ext uri="{FF2B5EF4-FFF2-40B4-BE49-F238E27FC236}">
+              <a16:creationId xmlns:a16="http://schemas.microsoft.com/office/drawing/2014/main" id="{5C51AE17-F9DE-D073-0CD5-8BF76786EAAD}"/>
+            </a:ext>
+          </a:extLst>
+        </p:cNvPr>
+        <p:cNvGrpSpPr/>
+        <p:nvPr/>
+      </p:nvGrpSpPr>
+      <p:grpSpPr>
+        <a:xfrm>
+          <a:off x="0" y="0"/>
+          <a:ext cx="0" cy="0"/>
+          <a:chOff x="0" y="0"/>
+          <a:chExt cx="0" cy="0"/>
+        </a:xfrm>
+      </p:grpSpPr>
+      <p:pic>
+        <p:nvPicPr>
+          <p:cNvPr id="5" name="Imagem 4">
+            <a:extLst>
+              <a:ext uri="{FF2B5EF4-FFF2-40B4-BE49-F238E27FC236}">
+                <a16:creationId xmlns:a16="http://schemas.microsoft.com/office/drawing/2014/main" id="{0ADD6EB5-9D40-73DE-2B4D-F6381CDA99E7}"/>
+              </a:ext>
+            </a:extLst>
+          </p:cNvPr>
+          <p:cNvPicPr>
+            <a:picLocks noChangeAspect="1"/>
+          </p:cNvPicPr>
+          <p:nvPr/>
+        </p:nvPicPr>
+        <p:blipFill>
+          <a:blip r:embed="rId2">
+            <a:extLst>
+              <a:ext uri="{28A0092B-C50C-407E-A947-70E740481C1C}">
+                <a14:useLocalDpi xmlns:a14="http://schemas.microsoft.com/office/drawing/2010/main" val="0"/>
+              </a:ext>
+            </a:extLst>
+          </a:blip>
+          <a:stretch>
+            <a:fillRect/>
+          </a:stretch>
+        </p:blipFill>
+        <p:spPr>
+          <a:xfrm>
+            <a:off x="0" y="0"/>
+            <a:ext cx="12192000" cy="6858000"/>
+          </a:xfrm>
+          <a:prstGeom prst="rect">
+            <a:avLst/>
+          </a:prstGeom>
+        </p:spPr>
+      </p:pic>
+      <p:sp>
+        <p:nvSpPr>
+          <p:cNvPr id="10" name="CaixaDeTexto 9">
+            <a:extLst>
+              <a:ext uri="{FF2B5EF4-FFF2-40B4-BE49-F238E27FC236}">
+                <a16:creationId xmlns:a16="http://schemas.microsoft.com/office/drawing/2014/main" id="{7EF9231B-72DF-6E85-1602-AC78194374C5}"/>
+              </a:ext>
+            </a:extLst>
+          </p:cNvPr>
+          <p:cNvSpPr txBox="1"/>
+          <p:nvPr/>
+        </p:nvSpPr>
+        <p:spPr>
+          <a:xfrm>
+            <a:off x="4866832" y="253160"/>
+            <a:ext cx="2447604" cy="584775"/>
+          </a:xfrm>
+          <a:prstGeom prst="rect">
+            <a:avLst/>
+          </a:prstGeom>
+          <a:noFill/>
+        </p:spPr>
+        <p:txBody>
+          <a:bodyPr wrap="square" lIns="91440" tIns="45720" rIns="91440" bIns="45720" rtlCol="0" anchor="t">
+            <a:spAutoFit/>
+          </a:bodyPr>
+          <a:lstStyle/>
+          <a:p>
+            <a:r>
+              <a:rPr lang="en-US" sz="3200"/>
+              <a:t>Casos de Uso</a:t>
+            </a:r>
+            <a:endParaRPr lang="en-US" sz="3200">
+              <a:ea typeface="Calibri"/>
+              <a:cs typeface="Calibri"/>
+            </a:endParaRPr>
+          </a:p>
+        </p:txBody>
+      </p:sp>
+      <p:sp>
+        <p:nvSpPr>
+          <p:cNvPr id="2" name="Retângulo: Cantos Arredondados 1">
+            <a:extLst>
+              <a:ext uri="{FF2B5EF4-FFF2-40B4-BE49-F238E27FC236}">
+                <a16:creationId xmlns:a16="http://schemas.microsoft.com/office/drawing/2014/main" id="{643B98C5-DE16-8F40-A70E-77EF46785C5E}"/>
+              </a:ext>
+            </a:extLst>
+          </p:cNvPr>
+          <p:cNvSpPr/>
+          <p:nvPr/>
+        </p:nvSpPr>
+        <p:spPr>
+          <a:xfrm>
+            <a:off x="912253" y="1105436"/>
+            <a:ext cx="10335295" cy="5076422"/>
+          </a:xfrm>
+          <a:prstGeom prst="roundRect">
+            <a:avLst/>
+          </a:prstGeom>
+        </p:spPr>
+        <p:style>
+          <a:lnRef idx="1">
+            <a:schemeClr val="accent5"/>
+          </a:lnRef>
+          <a:fillRef idx="2">
+            <a:schemeClr val="accent5"/>
+          </a:fillRef>
+          <a:effectRef idx="1">
+            <a:schemeClr val="accent5"/>
+          </a:effectRef>
+          <a:fontRef idx="minor">
+            <a:schemeClr val="dk1"/>
+          </a:fontRef>
+        </p:style>
+        <p:txBody>
+          <a:bodyPr rtlCol="0" anchor="ctr"/>
+          <a:lstStyle/>
+          <a:p>
+            <a:pPr algn="ctr"/>
+            <a:endParaRPr lang="pt-BR"/>
+          </a:p>
+        </p:txBody>
+      </p:sp>
+      <p:pic>
+        <p:nvPicPr>
+          <p:cNvPr id="6" name="Imagem 5" descr="Dicas para E-Commerce! - NC SISTEMAS WEBSITES">
+            <a:extLst>
+              <a:ext uri="{FF2B5EF4-FFF2-40B4-BE49-F238E27FC236}">
+                <a16:creationId xmlns:a16="http://schemas.microsoft.com/office/drawing/2014/main" id="{A804D9CC-6A78-9A1C-843C-729D3F973D98}"/>
+              </a:ext>
+            </a:extLst>
+          </p:cNvPr>
+          <p:cNvPicPr>
+            <a:picLocks noChangeAspect="1"/>
+          </p:cNvPicPr>
+          <p:nvPr/>
+        </p:nvPicPr>
+        <p:blipFill>
+          <a:blip r:embed="rId3"/>
+          <a:stretch>
+            <a:fillRect/>
+          </a:stretch>
+        </p:blipFill>
+        <p:spPr>
+          <a:xfrm>
+            <a:off x="1917276" y="2148022"/>
+            <a:ext cx="2959056" cy="2991252"/>
+          </a:xfrm>
+          <a:prstGeom prst="round2DiagRect">
+            <a:avLst>
+              <a:gd name="adj1" fmla="val 16667"/>
+              <a:gd name="adj2" fmla="val 0"/>
+            </a:avLst>
+          </a:prstGeom>
+          <a:ln w="88900" cap="sq">
+            <a:solidFill>
+              <a:srgbClr val="FFFFFF"/>
+            </a:solidFill>
+            <a:miter lim="800000"/>
+          </a:ln>
+          <a:effectLst>
+            <a:outerShdw blurRad="254000" algn="tl" rotWithShape="0">
+              <a:srgbClr val="000000">
+                <a:alpha val="43000"/>
+              </a:srgbClr>
+            </a:outerShdw>
+          </a:effectLst>
+        </p:spPr>
+      </p:pic>
+      <p:pic>
+        <p:nvPicPr>
+          <p:cNvPr id="7" name="Imagem 6" descr="Integração bancária: saiba o que é e qual sua importância - eSales">
+            <a:extLst>
+              <a:ext uri="{FF2B5EF4-FFF2-40B4-BE49-F238E27FC236}">
+                <a16:creationId xmlns:a16="http://schemas.microsoft.com/office/drawing/2014/main" id="{1A361F03-2350-C190-EBF3-B0D9E8244DCF}"/>
+              </a:ext>
+            </a:extLst>
+          </p:cNvPr>
+          <p:cNvPicPr>
+            <a:picLocks noChangeAspect="1"/>
+          </p:cNvPicPr>
+          <p:nvPr/>
+        </p:nvPicPr>
+        <p:blipFill>
+          <a:blip r:embed="rId4"/>
+          <a:stretch>
+            <a:fillRect/>
+          </a:stretch>
+        </p:blipFill>
+        <p:spPr>
+          <a:xfrm>
+            <a:off x="6092645" y="2144400"/>
+            <a:ext cx="4417723" cy="2998496"/>
+          </a:xfrm>
+          <a:prstGeom prst="round2DiagRect">
+            <a:avLst>
+              <a:gd name="adj1" fmla="val 16667"/>
+              <a:gd name="adj2" fmla="val 0"/>
+            </a:avLst>
+          </a:prstGeom>
+          <a:ln w="88900" cap="sq">
+            <a:solidFill>
+              <a:srgbClr val="FFFFFF"/>
+            </a:solidFill>
+            <a:miter lim="800000"/>
+          </a:ln>
+          <a:effectLst>
+            <a:outerShdw blurRad="254000" algn="tl" rotWithShape="0">
+              <a:srgbClr val="000000">
+                <a:alpha val="43000"/>
+              </a:srgbClr>
+            </a:outerShdw>
+          </a:effectLst>
+        </p:spPr>
+      </p:pic>
+    </p:spTree>
+    <p:extLst>
+      <p:ext uri="{BB962C8B-B14F-4D97-AF65-F5344CB8AC3E}">
+        <p14:creationId xmlns:p14="http://schemas.microsoft.com/office/powerpoint/2010/main" val="584384489"/>
+      </p:ext>
+    </p:extLst>
+  </p:cSld>
+  <p:clrMapOvr>
+    <a:masterClrMapping/>
+  </p:clrMapOvr>
+</p:sld>
+</file>
+
+<file path=ppt/slides/slide6.xml><?xml version="1.0" encoding="utf-8"?>
 <p:sld xmlns:a="http://schemas.openxmlformats.org/drawingml/2006/main" xmlns:r="http://schemas.openxmlformats.org/officeDocument/2006/relationships" xmlns:p="http://schemas.openxmlformats.org/presentationml/2006/main">
   <p:cSld>
     <p:spTree>
@@ -7553,7 +8993,7 @@
 </p:sld>
 </file>
 
-<file path=ppt/slides/slide5.xml><?xml version="1.0" encoding="utf-8"?>
+<file path=ppt/slides/slide7.xml><?xml version="1.0" encoding="utf-8"?>
 <p:sld xmlns:a="http://schemas.openxmlformats.org/drawingml/2006/main" xmlns:r="http://schemas.openxmlformats.org/officeDocument/2006/relationships" xmlns:p="http://schemas.openxmlformats.org/presentationml/2006/main">
   <p:cSld>
     <p:spTree>
@@ -7788,7 +9228,7 @@
 </p:sld>
 </file>
 
-<file path=ppt/slides/slide6.xml><?xml version="1.0" encoding="utf-8"?>
+<file path=ppt/slides/slide8.xml><?xml version="1.0" encoding="utf-8"?>
 <p:sld xmlns:a="http://schemas.openxmlformats.org/drawingml/2006/main" xmlns:r="http://schemas.openxmlformats.org/officeDocument/2006/relationships" xmlns:p="http://schemas.openxmlformats.org/presentationml/2006/main">
   <p:cSld>
     <p:spTree>
@@ -8130,7 +9570,7 @@
 </p:sld>
 </file>
 
-<file path=ppt/slides/slide7.xml><?xml version="1.0" encoding="utf-8"?>
+<file path=ppt/slides/slide9.xml><?xml version="1.0" encoding="utf-8"?>
 <p:sld xmlns:a="http://schemas.openxmlformats.org/drawingml/2006/main" xmlns:r="http://schemas.openxmlformats.org/officeDocument/2006/relationships" xmlns:p="http://schemas.openxmlformats.org/presentationml/2006/main">
   <p:cSld>
     <p:spTree>
@@ -8877,863 +10317,6 @@
     <p:extLst>
       <p:ext uri="{BB962C8B-B14F-4D97-AF65-F5344CB8AC3E}">
         <p14:creationId xmlns:p14="http://schemas.microsoft.com/office/powerpoint/2010/main" val="3068825762"/>
-      </p:ext>
-    </p:extLst>
-  </p:cSld>
-  <p:clrMapOvr>
-    <a:masterClrMapping/>
-  </p:clrMapOvr>
-</p:sld>
-</file>
-
-<file path=ppt/slides/slide8.xml><?xml version="1.0" encoding="utf-8"?>
-<p:sld xmlns:a="http://schemas.openxmlformats.org/drawingml/2006/main" xmlns:r="http://schemas.openxmlformats.org/officeDocument/2006/relationships" xmlns:p="http://schemas.openxmlformats.org/presentationml/2006/main">
-  <p:cSld>
-    <p:spTree>
-      <p:nvGrpSpPr>
-        <p:cNvPr id="1" name="">
-          <a:extLst>
-            <a:ext uri="{FF2B5EF4-FFF2-40B4-BE49-F238E27FC236}">
-              <a16:creationId xmlns:a16="http://schemas.microsoft.com/office/drawing/2014/main" id="{D783D399-0E22-4E3B-364D-D0374FFAB398}"/>
-            </a:ext>
-          </a:extLst>
-        </p:cNvPr>
-        <p:cNvGrpSpPr/>
-        <p:nvPr/>
-      </p:nvGrpSpPr>
-      <p:grpSpPr>
-        <a:xfrm>
-          <a:off x="0" y="0"/>
-          <a:ext cx="0" cy="0"/>
-          <a:chOff x="0" y="0"/>
-          <a:chExt cx="0" cy="0"/>
-        </a:xfrm>
-      </p:grpSpPr>
-      <p:sp>
-        <p:nvSpPr>
-          <p:cNvPr id="2" name="Título 1">
-            <a:extLst>
-              <a:ext uri="{FF2B5EF4-FFF2-40B4-BE49-F238E27FC236}">
-                <a16:creationId xmlns:a16="http://schemas.microsoft.com/office/drawing/2014/main" id="{8A7A24F0-3283-32F7-52BA-CB6E49BC7791}"/>
-              </a:ext>
-            </a:extLst>
-          </p:cNvPr>
-          <p:cNvSpPr>
-            <a:spLocks noGrp="1"/>
-          </p:cNvSpPr>
-          <p:nvPr>
-            <p:ph type="title"/>
-          </p:nvPr>
-        </p:nvSpPr>
-        <p:spPr/>
-        <p:txBody>
-          <a:bodyPr/>
-          <a:lstStyle/>
-          <a:p>
-            <a:endParaRPr lang="pt-BR"/>
-          </a:p>
-        </p:txBody>
-      </p:sp>
-      <p:sp>
-        <p:nvSpPr>
-          <p:cNvPr id="3" name="Espaço Reservado para Conteúdo 2">
-            <a:extLst>
-              <a:ext uri="{FF2B5EF4-FFF2-40B4-BE49-F238E27FC236}">
-                <a16:creationId xmlns:a16="http://schemas.microsoft.com/office/drawing/2014/main" id="{D5BD90EA-17CD-6205-3B39-487EEEC2E38C}"/>
-              </a:ext>
-            </a:extLst>
-          </p:cNvPr>
-          <p:cNvSpPr>
-            <a:spLocks noGrp="1"/>
-          </p:cNvSpPr>
-          <p:nvPr>
-            <p:ph idx="1"/>
-          </p:nvPr>
-        </p:nvSpPr>
-        <p:spPr/>
-        <p:txBody>
-          <a:bodyPr/>
-          <a:lstStyle/>
-          <a:p>
-            <a:endParaRPr lang="pt-BR"/>
-          </a:p>
-        </p:txBody>
-      </p:sp>
-      <p:pic>
-        <p:nvPicPr>
-          <p:cNvPr id="4" name="Imagem 3">
-            <a:extLst>
-              <a:ext uri="{FF2B5EF4-FFF2-40B4-BE49-F238E27FC236}">
-                <a16:creationId xmlns:a16="http://schemas.microsoft.com/office/drawing/2014/main" id="{11907E70-2A94-1DCF-C0B5-04AD6BA33CA4}"/>
-              </a:ext>
-            </a:extLst>
-          </p:cNvPr>
-          <p:cNvPicPr>
-            <a:picLocks noChangeAspect="1"/>
-          </p:cNvPicPr>
-          <p:nvPr/>
-        </p:nvPicPr>
-        <p:blipFill>
-          <a:blip r:embed="rId2">
-            <a:extLst>
-              <a:ext uri="{28A0092B-C50C-407E-A947-70E740481C1C}">
-                <a14:useLocalDpi xmlns:a14="http://schemas.microsoft.com/office/drawing/2010/main" val="0"/>
-              </a:ext>
-            </a:extLst>
-          </a:blip>
-          <a:stretch>
-            <a:fillRect/>
-          </a:stretch>
-        </p:blipFill>
-        <p:spPr>
-          <a:xfrm>
-            <a:off x="0" y="0"/>
-            <a:ext cx="12192000" cy="6858000"/>
-          </a:xfrm>
-          <a:prstGeom prst="rect">
-            <a:avLst/>
-          </a:prstGeom>
-        </p:spPr>
-      </p:pic>
-      <p:sp>
-        <p:nvSpPr>
-          <p:cNvPr id="5" name="CaixaDeTexto 4">
-            <a:extLst>
-              <a:ext uri="{FF2B5EF4-FFF2-40B4-BE49-F238E27FC236}">
-                <a16:creationId xmlns:a16="http://schemas.microsoft.com/office/drawing/2014/main" id="{269F7BF0-B16D-F005-3C99-877B66C74A60}"/>
-              </a:ext>
-            </a:extLst>
-          </p:cNvPr>
-          <p:cNvSpPr txBox="1"/>
-          <p:nvPr/>
-        </p:nvSpPr>
-        <p:spPr>
-          <a:xfrm>
-            <a:off x="4226902" y="498257"/>
-            <a:ext cx="3738196" cy="646331"/>
-          </a:xfrm>
-          <a:prstGeom prst="rect">
-            <a:avLst/>
-          </a:prstGeom>
-          <a:noFill/>
-        </p:spPr>
-        <p:txBody>
-          <a:bodyPr wrap="square" rtlCol="0">
-            <a:spAutoFit/>
-          </a:bodyPr>
-          <a:lstStyle/>
-          <a:p>
-            <a:pPr algn="ctr"/>
-            <a:r>
-              <a:rPr lang="pt-BR" sz="3600" dirty="0"/>
-              <a:t>CHAR x VARCHAR</a:t>
-            </a:r>
-          </a:p>
-        </p:txBody>
-      </p:sp>
-      <p:sp>
-        <p:nvSpPr>
-          <p:cNvPr id="7" name="CaixaDeTexto 6">
-            <a:extLst>
-              <a:ext uri="{FF2B5EF4-FFF2-40B4-BE49-F238E27FC236}">
-                <a16:creationId xmlns:a16="http://schemas.microsoft.com/office/drawing/2014/main" id="{BA5192B5-CF7F-F0C1-0A40-333626E1B5C5}"/>
-              </a:ext>
-            </a:extLst>
-          </p:cNvPr>
-          <p:cNvSpPr txBox="1"/>
-          <p:nvPr/>
-        </p:nvSpPr>
-        <p:spPr>
-          <a:xfrm>
-            <a:off x="838200" y="336950"/>
-            <a:ext cx="2467708" cy="1477328"/>
-          </a:xfrm>
-          <a:prstGeom prst="rect">
-            <a:avLst/>
-          </a:prstGeom>
-        </p:spPr>
-        <p:style>
-          <a:lnRef idx="0">
-            <a:schemeClr val="accent6"/>
-          </a:lnRef>
-          <a:fillRef idx="3">
-            <a:schemeClr val="accent6"/>
-          </a:fillRef>
-          <a:effectRef idx="3">
-            <a:schemeClr val="accent6"/>
-          </a:effectRef>
-          <a:fontRef idx="minor">
-            <a:schemeClr val="lt1"/>
-          </a:fontRef>
-        </p:style>
-        <p:txBody>
-          <a:bodyPr wrap="square" rtlCol="0">
-            <a:spAutoFit/>
-          </a:bodyPr>
-          <a:lstStyle/>
-          <a:p>
-            <a:r>
-              <a:rPr lang="en-US" dirty="0"/>
-              <a:t>String</a:t>
-            </a:r>
-          </a:p>
-          <a:p>
-            <a:endParaRPr lang="en-US" dirty="0"/>
-          </a:p>
-          <a:p>
-            <a:pPr marL="285750" indent="-285750">
-              <a:buFont typeface="Arial" panose="020B0604020202020204" pitchFamily="34" charset="0"/>
-              <a:buChar char="•"/>
-            </a:pPr>
-            <a:r>
-              <a:rPr lang="en-US" dirty="0"/>
-              <a:t>CHAR(n);</a:t>
-            </a:r>
-          </a:p>
-          <a:p>
-            <a:pPr marL="285750" indent="-285750">
-              <a:buFont typeface="Arial" panose="020B0604020202020204" pitchFamily="34" charset="0"/>
-              <a:buChar char="•"/>
-            </a:pPr>
-            <a:r>
-              <a:rPr lang="en-US" dirty="0"/>
-              <a:t>VARCHAR(n);</a:t>
-            </a:r>
-          </a:p>
-          <a:p>
-            <a:pPr marL="285750" indent="-285750">
-              <a:buFont typeface="Arial" panose="020B0604020202020204" pitchFamily="34" charset="0"/>
-              <a:buChar char="•"/>
-            </a:pPr>
-            <a:r>
-              <a:rPr lang="en-US" dirty="0"/>
-              <a:t>TEXT.</a:t>
-            </a:r>
-            <a:endParaRPr lang="pt-BR" dirty="0"/>
-          </a:p>
-        </p:txBody>
-      </p:sp>
-      <p:sp>
-        <p:nvSpPr>
-          <p:cNvPr id="13" name="Retângulo: Cantos Arredondados 12">
-            <a:extLst>
-              <a:ext uri="{FF2B5EF4-FFF2-40B4-BE49-F238E27FC236}">
-                <a16:creationId xmlns:a16="http://schemas.microsoft.com/office/drawing/2014/main" id="{76DEAC94-F68B-2F70-754B-561B241836AA}"/>
-              </a:ext>
-            </a:extLst>
-          </p:cNvPr>
-          <p:cNvSpPr/>
-          <p:nvPr/>
-        </p:nvSpPr>
-        <p:spPr>
-          <a:xfrm>
-            <a:off x="1169376" y="909949"/>
-            <a:ext cx="1371600" cy="606669"/>
-          </a:xfrm>
-          <a:prstGeom prst="roundRect">
-            <a:avLst/>
-          </a:prstGeom>
-          <a:solidFill>
-            <a:schemeClr val="accent2">
-              <a:alpha val="50000"/>
-            </a:schemeClr>
-          </a:solidFill>
-          <a:ln>
-            <a:noFill/>
-          </a:ln>
-        </p:spPr>
-        <p:style>
-          <a:lnRef idx="0">
-            <a:scrgbClr r="0" g="0" b="0"/>
-          </a:lnRef>
-          <a:fillRef idx="0">
-            <a:scrgbClr r="0" g="0" b="0"/>
-          </a:fillRef>
-          <a:effectRef idx="0">
-            <a:scrgbClr r="0" g="0" b="0"/>
-          </a:effectRef>
-          <a:fontRef idx="minor">
-            <a:schemeClr val="lt1"/>
-          </a:fontRef>
-        </p:style>
-        <p:txBody>
-          <a:bodyPr rtlCol="0" anchor="ctr"/>
-          <a:lstStyle/>
-          <a:p>
-            <a:pPr algn="ctr"/>
-            <a:endParaRPr lang="pt-BR"/>
-          </a:p>
-        </p:txBody>
-      </p:sp>
-      <p:pic>
-        <p:nvPicPr>
-          <p:cNvPr id="2050" name="Picture 2" descr="Caixa Tampa Sapato Medida: 20x30x12 - 3mm">
-            <a:extLst>
-              <a:ext uri="{FF2B5EF4-FFF2-40B4-BE49-F238E27FC236}">
-                <a16:creationId xmlns:a16="http://schemas.microsoft.com/office/drawing/2014/main" id="{4AF0CFC5-CB1E-C7ED-34C4-8C894B8CE690}"/>
-              </a:ext>
-            </a:extLst>
-          </p:cNvPr>
-          <p:cNvPicPr>
-            <a:picLocks noChangeAspect="1" noChangeArrowheads="1"/>
-          </p:cNvPicPr>
-          <p:nvPr/>
-        </p:nvPicPr>
-        <p:blipFill>
-          <a:blip r:embed="rId3">
-            <a:extLst>
-              <a:ext uri="{28A0092B-C50C-407E-A947-70E740481C1C}">
-                <a14:useLocalDpi xmlns:a14="http://schemas.microsoft.com/office/drawing/2010/main" val="0"/>
-              </a:ext>
-            </a:extLst>
-          </a:blip>
-          <a:srcRect/>
-          <a:stretch>
-            <a:fillRect/>
-          </a:stretch>
-        </p:blipFill>
-        <p:spPr bwMode="auto">
-          <a:xfrm>
-            <a:off x="1169376" y="2699726"/>
-            <a:ext cx="4648200" cy="3409950"/>
-          </a:xfrm>
-          <a:prstGeom prst="rect">
-            <a:avLst/>
-          </a:prstGeom>
-          <a:noFill/>
-          <a:extLst>
-            <a:ext uri="{909E8E84-426E-40DD-AFC4-6F175D3DCCD1}">
-              <a14:hiddenFill xmlns:a14="http://schemas.microsoft.com/office/drawing/2010/main">
-                <a:solidFill>
-                  <a:srgbClr val="FFFFFF"/>
-                </a:solidFill>
-              </a14:hiddenFill>
-            </a:ext>
-          </a:extLst>
-        </p:spPr>
-      </p:pic>
-      <p:pic>
-        <p:nvPicPr>
-          <p:cNvPr id="2054" name="Picture 6" descr="Mochila Saco em TNT CB 18505 | Célo Presentes Personalizados">
-            <a:extLst>
-              <a:ext uri="{FF2B5EF4-FFF2-40B4-BE49-F238E27FC236}">
-                <a16:creationId xmlns:a16="http://schemas.microsoft.com/office/drawing/2014/main" id="{9D1D9185-5185-BCC4-DAD0-A0103616B5B8}"/>
-              </a:ext>
-            </a:extLst>
-          </p:cNvPr>
-          <p:cNvPicPr>
-            <a:picLocks noChangeAspect="1" noChangeArrowheads="1"/>
-          </p:cNvPicPr>
-          <p:nvPr/>
-        </p:nvPicPr>
-        <p:blipFill>
-          <a:blip r:embed="rId4">
-            <a:extLst>
-              <a:ext uri="{28A0092B-C50C-407E-A947-70E740481C1C}">
-                <a14:useLocalDpi xmlns:a14="http://schemas.microsoft.com/office/drawing/2010/main" val="0"/>
-              </a:ext>
-            </a:extLst>
-          </a:blip>
-          <a:srcRect/>
-          <a:stretch>
-            <a:fillRect/>
-          </a:stretch>
-        </p:blipFill>
-        <p:spPr bwMode="auto">
-          <a:xfrm>
-            <a:off x="7342677" y="2497016"/>
-            <a:ext cx="3679947" cy="3679947"/>
-          </a:xfrm>
-          <a:prstGeom prst="rect">
-            <a:avLst/>
-          </a:prstGeom>
-          <a:noFill/>
-          <a:extLst>
-            <a:ext uri="{909E8E84-426E-40DD-AFC4-6F175D3DCCD1}">
-              <a14:hiddenFill xmlns:a14="http://schemas.microsoft.com/office/drawing/2010/main">
-                <a:solidFill>
-                  <a:srgbClr val="FFFFFF"/>
-                </a:solidFill>
-              </a14:hiddenFill>
-            </a:ext>
-          </a:extLst>
-        </p:spPr>
-      </p:pic>
-      <p:sp>
-        <p:nvSpPr>
-          <p:cNvPr id="14" name="CaixaDeTexto 13">
-            <a:extLst>
-              <a:ext uri="{FF2B5EF4-FFF2-40B4-BE49-F238E27FC236}">
-                <a16:creationId xmlns:a16="http://schemas.microsoft.com/office/drawing/2014/main" id="{F5A10B96-3C0E-403F-5742-D557A3C6C448}"/>
-              </a:ext>
-            </a:extLst>
-          </p:cNvPr>
-          <p:cNvSpPr txBox="1"/>
-          <p:nvPr/>
-        </p:nvSpPr>
-        <p:spPr>
-          <a:xfrm>
-            <a:off x="3031880" y="6311900"/>
-            <a:ext cx="923192" cy="461665"/>
-          </a:xfrm>
-          <a:prstGeom prst="rect">
-            <a:avLst/>
-          </a:prstGeom>
-          <a:noFill/>
-        </p:spPr>
-        <p:txBody>
-          <a:bodyPr wrap="square" rtlCol="0">
-            <a:spAutoFit/>
-          </a:bodyPr>
-          <a:lstStyle/>
-          <a:p>
-            <a:r>
-              <a:rPr lang="pt-BR" sz="2400" dirty="0"/>
-              <a:t>CHAR</a:t>
-            </a:r>
-          </a:p>
-        </p:txBody>
-      </p:sp>
-      <p:sp>
-        <p:nvSpPr>
-          <p:cNvPr id="15" name="CaixaDeTexto 14">
-            <a:extLst>
-              <a:ext uri="{FF2B5EF4-FFF2-40B4-BE49-F238E27FC236}">
-                <a16:creationId xmlns:a16="http://schemas.microsoft.com/office/drawing/2014/main" id="{5DB9C59B-3357-E4BD-B326-51F407B56D68}"/>
-              </a:ext>
-            </a:extLst>
-          </p:cNvPr>
-          <p:cNvSpPr txBox="1"/>
-          <p:nvPr/>
-        </p:nvSpPr>
-        <p:spPr>
-          <a:xfrm>
-            <a:off x="8491995" y="6227298"/>
-            <a:ext cx="1381309" cy="461665"/>
-          </a:xfrm>
-          <a:prstGeom prst="rect">
-            <a:avLst/>
-          </a:prstGeom>
-          <a:noFill/>
-        </p:spPr>
-        <p:txBody>
-          <a:bodyPr wrap="square" rtlCol="0">
-            <a:spAutoFit/>
-          </a:bodyPr>
-          <a:lstStyle/>
-          <a:p>
-            <a:r>
-              <a:rPr lang="pt-BR" sz="2400" dirty="0"/>
-              <a:t>VARCHAR</a:t>
-            </a:r>
-          </a:p>
-        </p:txBody>
-      </p:sp>
-      <p:sp>
-        <p:nvSpPr>
-          <p:cNvPr id="16" name="CaixaDeTexto 15">
-            <a:extLst>
-              <a:ext uri="{FF2B5EF4-FFF2-40B4-BE49-F238E27FC236}">
-                <a16:creationId xmlns:a16="http://schemas.microsoft.com/office/drawing/2014/main" id="{5D711219-99E7-7024-BCF6-8AF28AE1559F}"/>
-              </a:ext>
-            </a:extLst>
-          </p:cNvPr>
-          <p:cNvSpPr txBox="1"/>
-          <p:nvPr/>
-        </p:nvSpPr>
-        <p:spPr>
-          <a:xfrm>
-            <a:off x="8740377" y="4336989"/>
-            <a:ext cx="884544" cy="400110"/>
-          </a:xfrm>
-          <a:prstGeom prst="rect">
-            <a:avLst/>
-          </a:prstGeom>
-          <a:noFill/>
-        </p:spPr>
-        <p:txBody>
-          <a:bodyPr wrap="square" rtlCol="0">
-            <a:spAutoFit/>
-          </a:bodyPr>
-          <a:lstStyle/>
-          <a:p>
-            <a:r>
-              <a:rPr lang="pt-BR" sz="2000" dirty="0">
-                <a:solidFill>
-                  <a:schemeClr val="bg1"/>
-                </a:solidFill>
-              </a:rPr>
-              <a:t>Molde</a:t>
-            </a:r>
-            <a:r>
-              <a:rPr lang="pt-BR" dirty="0"/>
-              <a:t> </a:t>
-            </a:r>
-          </a:p>
-        </p:txBody>
-      </p:sp>
-      <p:sp>
-        <p:nvSpPr>
-          <p:cNvPr id="17" name="CaixaDeTexto 16">
-            <a:extLst>
-              <a:ext uri="{FF2B5EF4-FFF2-40B4-BE49-F238E27FC236}">
-                <a16:creationId xmlns:a16="http://schemas.microsoft.com/office/drawing/2014/main" id="{E09EC1C3-EA7A-9767-C1C8-C1EBD4CD0D15}"/>
-              </a:ext>
-            </a:extLst>
-          </p:cNvPr>
-          <p:cNvSpPr txBox="1"/>
-          <p:nvPr/>
-        </p:nvSpPr>
-        <p:spPr>
-          <a:xfrm>
-            <a:off x="2305781" y="3631962"/>
-            <a:ext cx="2375389" cy="369332"/>
-          </a:xfrm>
-          <a:prstGeom prst="rect">
-            <a:avLst/>
-          </a:prstGeom>
-          <a:noFill/>
-        </p:spPr>
-        <p:txBody>
-          <a:bodyPr wrap="square" rtlCol="0">
-            <a:spAutoFit/>
-          </a:bodyPr>
-          <a:lstStyle/>
-          <a:p>
-            <a:r>
-              <a:rPr lang="pt-BR" dirty="0">
-                <a:solidFill>
-                  <a:schemeClr val="bg1"/>
-                </a:solidFill>
-              </a:rPr>
-              <a:t>Caixa de tamanho Fixo</a:t>
-            </a:r>
-          </a:p>
-        </p:txBody>
-      </p:sp>
-    </p:spTree>
-    <p:extLst>
-      <p:ext uri="{BB962C8B-B14F-4D97-AF65-F5344CB8AC3E}">
-        <p14:creationId xmlns:p14="http://schemas.microsoft.com/office/powerpoint/2010/main" val="1799090681"/>
-      </p:ext>
-    </p:extLst>
-  </p:cSld>
-  <p:clrMapOvr>
-    <a:masterClrMapping/>
-  </p:clrMapOvr>
-</p:sld>
-</file>
-
-<file path=ppt/slides/slide9.xml><?xml version="1.0" encoding="utf-8"?>
-<p:sld xmlns:a="http://schemas.openxmlformats.org/drawingml/2006/main" xmlns:r="http://schemas.openxmlformats.org/officeDocument/2006/relationships" xmlns:p="http://schemas.openxmlformats.org/presentationml/2006/main">
-  <p:cSld>
-    <p:spTree>
-      <p:nvGrpSpPr>
-        <p:cNvPr id="1" name="">
-          <a:extLst>
-            <a:ext uri="{FF2B5EF4-FFF2-40B4-BE49-F238E27FC236}">
-              <a16:creationId xmlns:a16="http://schemas.microsoft.com/office/drawing/2014/main" id="{29B56F5F-7B90-0286-D0AC-48C7B7559BF2}"/>
-            </a:ext>
-          </a:extLst>
-        </p:cNvPr>
-        <p:cNvGrpSpPr/>
-        <p:nvPr/>
-      </p:nvGrpSpPr>
-      <p:grpSpPr>
-        <a:xfrm>
-          <a:off x="0" y="0"/>
-          <a:ext cx="0" cy="0"/>
-          <a:chOff x="0" y="0"/>
-          <a:chExt cx="0" cy="0"/>
-        </a:xfrm>
-      </p:grpSpPr>
-      <p:pic>
-        <p:nvPicPr>
-          <p:cNvPr id="4" name="Imagem 3">
-            <a:extLst>
-              <a:ext uri="{FF2B5EF4-FFF2-40B4-BE49-F238E27FC236}">
-                <a16:creationId xmlns:a16="http://schemas.microsoft.com/office/drawing/2014/main" id="{52668181-0034-E595-230A-A3E3760967D5}"/>
-              </a:ext>
-            </a:extLst>
-          </p:cNvPr>
-          <p:cNvPicPr>
-            <a:picLocks noChangeAspect="1"/>
-          </p:cNvPicPr>
-          <p:nvPr/>
-        </p:nvPicPr>
-        <p:blipFill>
-          <a:blip r:embed="rId2">
-            <a:extLst>
-              <a:ext uri="{28A0092B-C50C-407E-A947-70E740481C1C}">
-                <a14:useLocalDpi xmlns:a14="http://schemas.microsoft.com/office/drawing/2010/main" val="0"/>
-              </a:ext>
-            </a:extLst>
-          </a:blip>
-          <a:stretch>
-            <a:fillRect/>
-          </a:stretch>
-        </p:blipFill>
-        <p:spPr>
-          <a:xfrm>
-            <a:off x="0" y="0"/>
-            <a:ext cx="12192000" cy="6858000"/>
-          </a:xfrm>
-          <a:prstGeom prst="rect">
-            <a:avLst/>
-          </a:prstGeom>
-        </p:spPr>
-      </p:pic>
-      <p:sp>
-        <p:nvSpPr>
-          <p:cNvPr id="5" name="CaixaDeTexto 4">
-            <a:extLst>
-              <a:ext uri="{FF2B5EF4-FFF2-40B4-BE49-F238E27FC236}">
-                <a16:creationId xmlns:a16="http://schemas.microsoft.com/office/drawing/2014/main" id="{8432ACAF-4D47-7516-C29C-FEB386218782}"/>
-              </a:ext>
-            </a:extLst>
-          </p:cNvPr>
-          <p:cNvSpPr txBox="1"/>
-          <p:nvPr/>
-        </p:nvSpPr>
-        <p:spPr>
-          <a:xfrm>
-            <a:off x="4955931" y="404324"/>
-            <a:ext cx="2203939" cy="646331"/>
-          </a:xfrm>
-          <a:prstGeom prst="rect">
-            <a:avLst/>
-          </a:prstGeom>
-          <a:noFill/>
-        </p:spPr>
-        <p:txBody>
-          <a:bodyPr wrap="square" rtlCol="0">
-            <a:spAutoFit/>
-          </a:bodyPr>
-          <a:lstStyle/>
-          <a:p>
-            <a:r>
-              <a:rPr lang="en-US" sz="3600" dirty="0"/>
-              <a:t>Null X Zero</a:t>
-            </a:r>
-            <a:endParaRPr lang="pt-BR" sz="3600" dirty="0"/>
-          </a:p>
-        </p:txBody>
-      </p:sp>
-      <p:sp>
-        <p:nvSpPr>
-          <p:cNvPr id="7" name="CaixaDeTexto 6">
-            <a:extLst>
-              <a:ext uri="{FF2B5EF4-FFF2-40B4-BE49-F238E27FC236}">
-                <a16:creationId xmlns:a16="http://schemas.microsoft.com/office/drawing/2014/main" id="{F30DE2AE-7BE7-BB5B-0BD0-416B40B9805B}"/>
-              </a:ext>
-            </a:extLst>
-          </p:cNvPr>
-          <p:cNvSpPr txBox="1"/>
-          <p:nvPr/>
-        </p:nvSpPr>
-        <p:spPr>
-          <a:xfrm>
-            <a:off x="1521069" y="1690688"/>
-            <a:ext cx="3434862" cy="1354217"/>
-          </a:xfrm>
-          <a:prstGeom prst="rect">
-            <a:avLst/>
-          </a:prstGeom>
-          <a:noFill/>
-        </p:spPr>
-        <p:txBody>
-          <a:bodyPr wrap="square" rtlCol="0">
-            <a:spAutoFit/>
-          </a:bodyPr>
-          <a:lstStyle/>
-          <a:p>
-            <a:r>
-              <a:rPr lang="pt-BR" sz="2800" dirty="0"/>
-              <a:t>	     </a:t>
-            </a:r>
-            <a:r>
-              <a:rPr lang="pt-BR" sz="2800" dirty="0" err="1"/>
-              <a:t>Null</a:t>
-            </a:r>
-            <a:endParaRPr lang="pt-BR" sz="2800" dirty="0"/>
-          </a:p>
-          <a:p>
-            <a:endParaRPr lang="pt-BR" dirty="0"/>
-          </a:p>
-          <a:p>
-            <a:pPr marL="285750" indent="-285750" algn="ctr">
-              <a:buFont typeface="Wingdings" panose="05000000000000000000" pitchFamily="2" charset="2"/>
-              <a:buChar char="Ø"/>
-            </a:pPr>
-            <a:r>
-              <a:rPr lang="pt-BR" dirty="0"/>
-              <a:t>É a </a:t>
-            </a:r>
-            <a:r>
-              <a:rPr lang="pt-BR" b="1" dirty="0"/>
-              <a:t>ausência</a:t>
-            </a:r>
-            <a:r>
-              <a:rPr lang="pt-BR" dirty="0"/>
-              <a:t> de valor, indicando que o valor é desconhecido.</a:t>
-            </a:r>
-          </a:p>
-        </p:txBody>
-      </p:sp>
-      <p:sp>
-        <p:nvSpPr>
-          <p:cNvPr id="8" name="CaixaDeTexto 7">
-            <a:extLst>
-              <a:ext uri="{FF2B5EF4-FFF2-40B4-BE49-F238E27FC236}">
-                <a16:creationId xmlns:a16="http://schemas.microsoft.com/office/drawing/2014/main" id="{A08F799F-3F3F-9C9A-C4A7-A84CC4A27875}"/>
-              </a:ext>
-            </a:extLst>
-          </p:cNvPr>
-          <p:cNvSpPr txBox="1"/>
-          <p:nvPr/>
-        </p:nvSpPr>
-        <p:spPr>
-          <a:xfrm>
-            <a:off x="7159870" y="1552188"/>
-            <a:ext cx="3285392" cy="1631216"/>
-          </a:xfrm>
-          <a:prstGeom prst="rect">
-            <a:avLst/>
-          </a:prstGeom>
-          <a:noFill/>
-        </p:spPr>
-        <p:txBody>
-          <a:bodyPr wrap="square" rtlCol="0">
-            <a:spAutoFit/>
-          </a:bodyPr>
-          <a:lstStyle/>
-          <a:p>
-            <a:r>
-              <a:rPr lang="pt-BR" sz="2800" dirty="0"/>
-              <a:t>	    Zero</a:t>
-            </a:r>
-          </a:p>
-          <a:p>
-            <a:endParaRPr lang="pt-BR" dirty="0"/>
-          </a:p>
-          <a:p>
-            <a:pPr marL="285750" indent="-285750" algn="ctr">
-              <a:buFont typeface="Wingdings" panose="05000000000000000000" pitchFamily="2" charset="2"/>
-              <a:buChar char="Ø"/>
-            </a:pPr>
-            <a:r>
-              <a:rPr lang="pt-BR" dirty="0"/>
-              <a:t>É um valor numérico </a:t>
-            </a:r>
-            <a:r>
-              <a:rPr lang="pt-BR" b="1" dirty="0"/>
-              <a:t>definido</a:t>
-            </a:r>
-            <a:r>
-              <a:rPr lang="pt-BR" dirty="0"/>
-              <a:t>, indicando que o valor foi preenchido.</a:t>
-            </a:r>
-          </a:p>
-        </p:txBody>
-      </p:sp>
-      <p:pic>
-        <p:nvPicPr>
-          <p:cNvPr id="1028" name="Picture 4" descr="Suporte Papeleira Com Tampa Para Papel Higiénico Aço Inox">
-            <a:extLst>
-              <a:ext uri="{FF2B5EF4-FFF2-40B4-BE49-F238E27FC236}">
-                <a16:creationId xmlns:a16="http://schemas.microsoft.com/office/drawing/2014/main" id="{F7002B80-0DCF-EF40-809F-5E2B97B61D91}"/>
-              </a:ext>
-            </a:extLst>
-          </p:cNvPr>
-          <p:cNvPicPr>
-            <a:picLocks noChangeAspect="1" noChangeArrowheads="1"/>
-          </p:cNvPicPr>
-          <p:nvPr/>
-        </p:nvPicPr>
-        <p:blipFill>
-          <a:blip r:embed="rId3">
-            <a:extLst>
-              <a:ext uri="{28A0092B-C50C-407E-A947-70E740481C1C}">
-                <a14:useLocalDpi xmlns:a14="http://schemas.microsoft.com/office/drawing/2010/main" val="0"/>
-              </a:ext>
-            </a:extLst>
-          </a:blip>
-          <a:srcRect/>
-          <a:stretch>
-            <a:fillRect/>
-          </a:stretch>
-        </p:blipFill>
-        <p:spPr bwMode="auto">
-          <a:xfrm>
-            <a:off x="1749944" y="3232823"/>
-            <a:ext cx="2972020" cy="2989959"/>
-          </a:xfrm>
-          <a:prstGeom prst="rect">
-            <a:avLst/>
-          </a:prstGeom>
-          <a:noFill/>
-          <a:extLst>
-            <a:ext uri="{909E8E84-426E-40DD-AFC4-6F175D3DCCD1}">
-              <a14:hiddenFill xmlns:a14="http://schemas.microsoft.com/office/drawing/2010/main">
-                <a:solidFill>
-                  <a:srgbClr val="FFFFFF"/>
-                </a:solidFill>
-              </a14:hiddenFill>
-            </a:ext>
-          </a:extLst>
-        </p:spPr>
-      </p:pic>
-      <p:pic>
-        <p:nvPicPr>
-          <p:cNvPr id="1030" name="Picture 6" descr="Rolo de papel higiênico de papelão vazio isolado em um branco | Foto Premium">
-            <a:extLst>
-              <a:ext uri="{FF2B5EF4-FFF2-40B4-BE49-F238E27FC236}">
-                <a16:creationId xmlns:a16="http://schemas.microsoft.com/office/drawing/2014/main" id="{CB8257F2-C99E-4E77-C501-117672B34C80}"/>
-              </a:ext>
-            </a:extLst>
-          </p:cNvPr>
-          <p:cNvPicPr>
-            <a:picLocks noChangeAspect="1" noChangeArrowheads="1"/>
-          </p:cNvPicPr>
-          <p:nvPr/>
-        </p:nvPicPr>
-        <p:blipFill>
-          <a:blip r:embed="rId4">
-            <a:extLst>
-              <a:ext uri="{28A0092B-C50C-407E-A947-70E740481C1C}">
-                <a14:useLocalDpi xmlns:a14="http://schemas.microsoft.com/office/drawing/2010/main" val="0"/>
-              </a:ext>
-            </a:extLst>
-          </a:blip>
-          <a:srcRect/>
-          <a:stretch>
-            <a:fillRect/>
-          </a:stretch>
-        </p:blipFill>
-        <p:spPr bwMode="auto">
-          <a:xfrm>
-            <a:off x="7470038" y="3232823"/>
-            <a:ext cx="2895800" cy="2938016"/>
-          </a:xfrm>
-          <a:prstGeom prst="rect">
-            <a:avLst/>
-          </a:prstGeom>
-          <a:noFill/>
-          <a:extLst>
-            <a:ext uri="{909E8E84-426E-40DD-AFC4-6F175D3DCCD1}">
-              <a14:hiddenFill xmlns:a14="http://schemas.microsoft.com/office/drawing/2010/main">
-                <a:solidFill>
-                  <a:srgbClr val="FFFFFF"/>
-                </a:solidFill>
-              </a14:hiddenFill>
-            </a:ext>
-          </a:extLst>
-        </p:spPr>
-      </p:pic>
-    </p:spTree>
-    <p:extLst>
-      <p:ext uri="{BB962C8B-B14F-4D97-AF65-F5344CB8AC3E}">
-        <p14:creationId xmlns:p14="http://schemas.microsoft.com/office/powerpoint/2010/main" val="1358784351"/>
       </p:ext>
     </p:extLst>
   </p:cSld>

</xml_diff>